<commit_message>
cleanup: remove broken bracket-expansion folder
</commit_message>
<xml_diff>
--- a/Capstone_Project/Credit-Risk-Intelligence-Platform/docs/Project_Documents/Credit_Risk_Platform_Capstone_project.pptx
+++ b/Capstone_Project/Credit-Risk-Intelligence-Platform/docs/Project_Documents/Credit_Risk_Platform_Capstone_project.pptx
@@ -6,7 +6,7 @@
     <p:sldMasterId id="2147483760" r:id="rId2"/>
   </p:sldMasterIdLst>
   <p:notesMasterIdLst>
-    <p:notesMasterId r:id="rId22"/>
+    <p:notesMasterId r:id="rId23"/>
   </p:notesMasterIdLst>
   <p:sldIdLst>
     <p:sldId id="256" r:id="rId3"/>
@@ -27,7 +27,8 @@
     <p:sldId id="264" r:id="rId18"/>
     <p:sldId id="266" r:id="rId19"/>
     <p:sldId id="269" r:id="rId20"/>
-    <p:sldId id="271" r:id="rId21"/>
+    <p:sldId id="310" r:id="rId21"/>
+    <p:sldId id="271" r:id="rId22"/>
   </p:sldIdLst>
   <p:sldSz cx="9144000" cy="5143500" type="screen16x9"/>
   <p:notesSz cx="5143500" cy="9144000"/>
@@ -387,10 +388,7 @@
           <a:bodyPr/>
           <a:lstStyle/>
           <a:p>
-            <a:r>
-              <a:rPr lang="en-US" dirty="0"/>
-              <a:t>Thank the audience. Offer to show the live app and LangSmith traces. Invite questions.</a:t>
-            </a:r>
+            <a:endParaRPr lang="en-US" dirty="0"/>
           </a:p>
         </p:txBody>
       </p:sp>
@@ -409,9 +407,156 @@
           <a:bodyPr/>
           <a:lstStyle/>
           <a:p>
+            <a:pPr marL="0" marR="0" lvl="0" indent="0" algn="l" defTabSz="914400" rtl="0" eaLnBrk="1" fontAlgn="auto" latinLnBrk="0" hangingPunct="1">
+              <a:lnSpc>
+                <a:spcPct val="100000"/>
+              </a:lnSpc>
+              <a:spcBef>
+                <a:spcPts val="0"/>
+              </a:spcBef>
+              <a:spcAft>
+                <a:spcPts val="0"/>
+              </a:spcAft>
+              <a:buClrTx/>
+              <a:buSzTx/>
+              <a:buFontTx/>
+              <a:buNone/>
+              <a:tabLst/>
+              <a:defRPr/>
+            </a:pPr>
+            <a:fld id="{F7021451-1387-4CA6-816F-3879F97B5CBC}" type="slidenum">
+              <a:rPr kumimoji="0" lang="en-US" sz="1800" b="0" i="0" u="none" strike="noStrike" kern="1200" cap="none" spc="0" normalizeH="0" baseline="0" noProof="0">
+                <a:ln>
+                  <a:noFill/>
+                </a:ln>
+                <a:solidFill>
+                  <a:prstClr val="black"/>
+                </a:solidFill>
+                <a:effectLst/>
+                <a:uLnTx/>
+                <a:uFillTx/>
+                <a:latin typeface="Calibri" panose="020F0502020204030204"/>
+                <a:ea typeface="+mn-ea"/>
+                <a:cs typeface="+mn-cs"/>
+              </a:rPr>
+              <a:pPr marL="0" marR="0" lvl="0" indent="0" algn="l" defTabSz="914400" rtl="0" eaLnBrk="1" fontAlgn="auto" latinLnBrk="0" hangingPunct="1">
+                <a:lnSpc>
+                  <a:spcPct val="100000"/>
+                </a:lnSpc>
+                <a:spcBef>
+                  <a:spcPts val="0"/>
+                </a:spcBef>
+                <a:spcAft>
+                  <a:spcPts val="0"/>
+                </a:spcAft>
+                <a:buClrTx/>
+                <a:buSzTx/>
+                <a:buFontTx/>
+                <a:buNone/>
+                <a:tabLst/>
+                <a:defRPr/>
+              </a:pPr>
+              <a:t>19</a:t>
+            </a:fld>
+            <a:endParaRPr kumimoji="0" lang="en-US" sz="1800" b="0" i="0" u="none" strike="noStrike" kern="1200" cap="none" spc="0" normalizeH="0" baseline="0" noProof="0">
+              <a:ln>
+                <a:noFill/>
+              </a:ln>
+              <a:solidFill>
+                <a:prstClr val="black"/>
+              </a:solidFill>
+              <a:effectLst/>
+              <a:uLnTx/>
+              <a:uFillTx/>
+              <a:latin typeface="Calibri" panose="020F0502020204030204"/>
+              <a:ea typeface="+mn-ea"/>
+              <a:cs typeface="+mn-cs"/>
+            </a:endParaRPr>
+          </a:p>
+        </p:txBody>
+      </p:sp>
+    </p:spTree>
+    <p:extLst>
+      <p:ext uri="{BB962C8B-B14F-4D97-AF65-F5344CB8AC3E}">
+        <p14:creationId xmlns:p14="http://schemas.microsoft.com/office/powerpoint/2010/main" val="2011497894"/>
+      </p:ext>
+    </p:extLst>
+  </p:cSld>
+  <p:clrMapOvr>
+    <a:masterClrMapping/>
+  </p:clrMapOvr>
+</p:notes>
+</file>
+
+<file path=ppt/notesSlides/notesSlide11.xml><?xml version="1.0" encoding="utf-8"?>
+<p:notes xmlns:a="http://schemas.openxmlformats.org/drawingml/2006/main" xmlns:r="http://schemas.openxmlformats.org/officeDocument/2006/relationships" xmlns:p="http://schemas.openxmlformats.org/presentationml/2006/main">
+  <p:cSld>
+    <p:spTree>
+      <p:nvGrpSpPr>
+        <p:cNvPr id="1" name=""/>
+        <p:cNvGrpSpPr/>
+        <p:nvPr/>
+      </p:nvGrpSpPr>
+      <p:grpSpPr>
+        <a:xfrm>
+          <a:off x="0" y="0"/>
+          <a:ext cx="0" cy="0"/>
+          <a:chOff x="0" y="0"/>
+          <a:chExt cx="0" cy="0"/>
+        </a:xfrm>
+      </p:grpSpPr>
+      <p:sp>
+        <p:nvSpPr>
+          <p:cNvPr id="2" name="Slide Image Placeholder 1"/>
+          <p:cNvSpPr>
+            <a:spLocks noGrp="1" noRot="1" noChangeAspect="1"/>
+          </p:cNvSpPr>
+          <p:nvPr>
+            <p:ph type="sldImg"/>
+          </p:nvPr>
+        </p:nvSpPr>
+        <p:spPr/>
+      </p:sp>
+      <p:sp>
+        <p:nvSpPr>
+          <p:cNvPr id="3" name="Notes Placeholder 2"/>
+          <p:cNvSpPr>
+            <a:spLocks noGrp="1"/>
+          </p:cNvSpPr>
+          <p:nvPr>
+            <p:ph type="body" idx="1"/>
+          </p:nvPr>
+        </p:nvSpPr>
+        <p:spPr/>
+        <p:txBody>
+          <a:bodyPr/>
+          <a:lstStyle/>
+          <a:p>
+            <a:r>
+              <a:rPr lang="en-US" dirty="0"/>
+              <a:t>Thank the audience. Offer to show the live app and LangSmith traces. Invite questions.</a:t>
+            </a:r>
+          </a:p>
+        </p:txBody>
+      </p:sp>
+      <p:sp>
+        <p:nvSpPr>
+          <p:cNvPr id="4" name="Slide Number Placeholder 3"/>
+          <p:cNvSpPr>
+            <a:spLocks noGrp="1"/>
+          </p:cNvSpPr>
+          <p:nvPr>
+            <p:ph type="sldNum" sz="quarter" idx="10"/>
+          </p:nvPr>
+        </p:nvSpPr>
+        <p:spPr/>
+        <p:txBody>
+          <a:bodyPr/>
+          <a:lstStyle/>
+          <a:p>
             <a:fld id="{F7021451-1387-4CA6-816F-3879F97B5CBC}" type="slidenum">
               <a:rPr lang="en-US"/>
-              <a:t>19</a:t>
+              <a:t>20</a:t>
             </a:fld>
             <a:endParaRPr lang="en-US"/>
           </a:p>
@@ -13767,7 +13912,7 @@
 
 <file path=ppt/slides/slide19.xml><?xml version="1.0" encoding="utf-8"?>
 <p:sld xmlns:a="http://schemas.openxmlformats.org/drawingml/2006/main" xmlns:r="http://schemas.openxmlformats.org/officeDocument/2006/relationships" xmlns:p="http://schemas.openxmlformats.org/presentationml/2006/main">
-  <p:cSld name="Slide 16">
+  <p:cSld>
     <p:bg>
       <p:bgPr>
         <a:solidFill>
@@ -13798,61 +13943,17 @@
         </p:nvSpPr>
         <p:spPr>
           <a:xfrm>
-            <a:off x="6858000" y="-914400"/>
-            <a:ext cx="3657600" cy="3657600"/>
-          </a:xfrm>
-          <a:prstGeom prst="ellipse">
-            <a:avLst/>
-          </a:prstGeom>
-          <a:solidFill>
-            <a:srgbClr val="2563EB">
-              <a:alpha val="12000"/>
-            </a:srgbClr>
-          </a:solidFill>
-          <a:ln/>
-        </p:spPr>
-      </p:sp>
-      <p:sp>
-        <p:nvSpPr>
-          <p:cNvPr id="3" name="Shape 1"/>
-          <p:cNvSpPr/>
-          <p:nvPr/>
-        </p:nvSpPr>
-        <p:spPr>
-          <a:xfrm>
-            <a:off x="-699967" y="2616086"/>
-            <a:ext cx="3200400" cy="3200400"/>
-          </a:xfrm>
-          <a:prstGeom prst="ellipse">
-            <a:avLst/>
-          </a:prstGeom>
-          <a:solidFill>
-            <a:srgbClr val="0891B2">
-              <a:alpha val="12000"/>
-            </a:srgbClr>
-          </a:solidFill>
-          <a:ln/>
-        </p:spPr>
-      </p:sp>
-      <p:sp>
-        <p:nvSpPr>
-          <p:cNvPr id="4" name="Shape 2"/>
-          <p:cNvSpPr/>
-          <p:nvPr/>
-        </p:nvSpPr>
-        <p:spPr>
-          <a:xfrm>
-            <a:off x="3474720" y="365760"/>
-            <a:ext cx="1280160" cy="256032"/>
+            <a:off x="457200" y="274320"/>
+            <a:ext cx="2286000" cy="256032"/>
           </a:xfrm>
           <a:prstGeom prst="roundRect">
             <a:avLst>
-              <a:gd name="adj" fmla="val 50000"/>
+              <a:gd name="adj" fmla="val 21429"/>
             </a:avLst>
           </a:prstGeom>
           <a:solidFill>
-            <a:srgbClr val="059669">
-              <a:alpha val="25000"/>
+            <a:srgbClr val="F5A623">
+              <a:alpha val="22000"/>
             </a:srgbClr>
           </a:solidFill>
           <a:ln/>
@@ -13860,14 +13961,14 @@
       </p:sp>
       <p:sp>
         <p:nvSpPr>
-          <p:cNvPr id="5" name="Text 3"/>
-          <p:cNvSpPr/>
-          <p:nvPr/>
-        </p:nvSpPr>
-        <p:spPr>
-          <a:xfrm>
-            <a:off x="3474720" y="365760"/>
-            <a:ext cx="1280160" cy="256032"/>
+          <p:cNvPr id="3" name="Text 1"/>
+          <p:cNvSpPr/>
+          <p:nvPr/>
+        </p:nvSpPr>
+        <p:spPr>
+          <a:xfrm>
+            <a:off x="457200" y="274320"/>
+            <a:ext cx="2286000" cy="256032"/>
           </a:xfrm>
           <a:prstGeom prst="rect">
             <a:avLst/>
@@ -13879,31 +13980,67 @@
           <a:bodyPr wrap="square" lIns="0" tIns="0" rIns="0" bIns="0" rtlCol="0" anchor="ctr"/>
           <a:lstStyle/>
           <a:p>
-            <a:pPr marL="0" indent="0" algn="ctr">
-              <a:buNone/>
-            </a:pPr>
-            <a:r>
-              <a:rPr lang="en-US" sz="900" b="1" kern="0" spc="150" dirty="0">
-                <a:solidFill>
-                  <a:srgbClr val="059669"/>
-                </a:solidFill>
-              </a:rPr>
-              <a:t>SUBMITTED</a:t>
-            </a:r>
-            <a:endParaRPr lang="en-US" sz="900" dirty="0"/>
-          </a:p>
-        </p:txBody>
-      </p:sp>
-      <p:sp>
-        <p:nvSpPr>
-          <p:cNvPr id="6" name="Text 4"/>
-          <p:cNvSpPr/>
-          <p:nvPr/>
-        </p:nvSpPr>
-        <p:spPr>
-          <a:xfrm>
-            <a:off x="91440" y="1275588"/>
-            <a:ext cx="8229600" cy="731520"/>
+            <a:pPr marL="0" marR="0" lvl="0" indent="0" algn="ctr" defTabSz="914400" rtl="0" eaLnBrk="1" fontAlgn="auto" latinLnBrk="0" hangingPunct="1">
+              <a:lnSpc>
+                <a:spcPct val="100000"/>
+              </a:lnSpc>
+              <a:spcBef>
+                <a:spcPts val="0"/>
+              </a:spcBef>
+              <a:spcAft>
+                <a:spcPts val="0"/>
+              </a:spcAft>
+              <a:buClrTx/>
+              <a:buSzTx/>
+              <a:buFontTx/>
+              <a:buNone/>
+              <a:tabLst/>
+              <a:defRPr/>
+            </a:pPr>
+            <a:r>
+              <a:rPr kumimoji="0" lang="en-US" sz="900" b="1" i="0" u="none" strike="noStrike" kern="0" cap="none" spc="120" normalizeH="0" baseline="0" noProof="0" dirty="0">
+                <a:ln>
+                  <a:noFill/>
+                </a:ln>
+                <a:solidFill>
+                  <a:srgbClr val="F5A623"/>
+                </a:solidFill>
+                <a:effectLst/>
+                <a:uLnTx/>
+                <a:uFillTx/>
+                <a:latin typeface="Calibri" pitchFamily="34" charset="0"/>
+                <a:ea typeface="Calibri" pitchFamily="34" charset="-122"/>
+                <a:cs typeface="Calibri" pitchFamily="34" charset="-120"/>
+              </a:rPr>
+              <a:t>EY GUIDELINES · IN PRACTICE</a:t>
+            </a:r>
+            <a:endParaRPr kumimoji="0" lang="en-US" sz="900" b="0" i="0" u="none" strike="noStrike" kern="1200" cap="none" spc="0" normalizeH="0" baseline="0" noProof="0" dirty="0">
+              <a:ln>
+                <a:noFill/>
+              </a:ln>
+              <a:solidFill>
+                <a:prstClr val="black"/>
+              </a:solidFill>
+              <a:effectLst/>
+              <a:uLnTx/>
+              <a:uFillTx/>
+              <a:latin typeface="Calibri" panose="020F0502020204030204"/>
+              <a:ea typeface="+mn-ea"/>
+              <a:cs typeface="+mn-cs"/>
+            </a:endParaRPr>
+          </a:p>
+        </p:txBody>
+      </p:sp>
+      <p:sp>
+        <p:nvSpPr>
+          <p:cNvPr id="4" name="Text 2"/>
+          <p:cNvSpPr/>
+          <p:nvPr/>
+        </p:nvSpPr>
+        <p:spPr>
+          <a:xfrm>
+            <a:off x="457200" y="566928"/>
+            <a:ext cx="8229600" cy="457200"/>
           </a:xfrm>
           <a:prstGeom prst="rect">
             <a:avLst/>
@@ -13915,48 +14052,158 @@
           <a:bodyPr wrap="square" lIns="0" tIns="0" rIns="0" bIns="0" rtlCol="0" anchor="ctr"/>
           <a:lstStyle/>
           <a:p>
-            <a:pPr marL="0" indent="0" algn="ctr">
-              <a:buNone/>
-            </a:pPr>
-            <a:r>
-              <a:rPr lang="en-US" sz="4800" b="1" dirty="0">
+            <a:pPr marL="0" marR="0" lvl="0" indent="0" algn="l" defTabSz="914400" rtl="0" eaLnBrk="1" fontAlgn="auto" latinLnBrk="0" hangingPunct="1">
+              <a:lnSpc>
+                <a:spcPct val="100000"/>
+              </a:lnSpc>
+              <a:spcBef>
+                <a:spcPts val="0"/>
+              </a:spcBef>
+              <a:spcAft>
+                <a:spcPts val="0"/>
+              </a:spcAft>
+              <a:buClrTx/>
+              <a:buSzTx/>
+              <a:buFontTx/>
+              <a:buNone/>
+              <a:tabLst/>
+              <a:defRPr/>
+            </a:pPr>
+            <a:r>
+              <a:rPr kumimoji="0" lang="en-US" sz="2200" b="1" i="0" u="none" strike="noStrike" kern="1200" cap="none" spc="0" normalizeH="0" baseline="0" noProof="0" dirty="0">
+                <a:ln>
+                  <a:noFill/>
+                </a:ln>
                 <a:solidFill>
                   <a:srgbClr val="FFFFFF"/>
                 </a:solidFill>
+                <a:effectLst/>
+                <a:uLnTx/>
+                <a:uFillTx/>
                 <a:latin typeface="Cambria" pitchFamily="34" charset="0"/>
                 <a:ea typeface="Cambria" pitchFamily="34" charset="-122"/>
                 <a:cs typeface="Cambria" pitchFamily="34" charset="-120"/>
               </a:rPr>
-              <a:t>Thank You</a:t>
-            </a:r>
-            <a:endParaRPr lang="en-US" sz="4800" dirty="0"/>
-          </a:p>
-        </p:txBody>
-      </p:sp>
-      <p:sp>
-        <p:nvSpPr>
-          <p:cNvPr id="8" name="Shape 6"/>
-          <p:cNvSpPr/>
-          <p:nvPr/>
-        </p:nvSpPr>
-        <p:spPr>
-          <a:xfrm>
-            <a:off x="822960" y="2423160"/>
-            <a:ext cx="3520440" cy="566928"/>
+              <a:t>How Our Project Followed EY Coding Guidelines</a:t>
+            </a:r>
+            <a:endParaRPr kumimoji="0" lang="en-US" sz="2200" b="0" i="0" u="none" strike="noStrike" kern="1200" cap="none" spc="0" normalizeH="0" baseline="0" noProof="0" dirty="0">
+              <a:ln>
+                <a:noFill/>
+              </a:ln>
+              <a:solidFill>
+                <a:prstClr val="black"/>
+              </a:solidFill>
+              <a:effectLst/>
+              <a:uLnTx/>
+              <a:uFillTx/>
+              <a:latin typeface="Calibri" panose="020F0502020204030204"/>
+              <a:ea typeface="+mn-ea"/>
+              <a:cs typeface="+mn-cs"/>
+            </a:endParaRPr>
+          </a:p>
+        </p:txBody>
+      </p:sp>
+      <p:sp>
+        <p:nvSpPr>
+          <p:cNvPr id="5" name="Text 3"/>
+          <p:cNvSpPr/>
+          <p:nvPr/>
+        </p:nvSpPr>
+        <p:spPr>
+          <a:xfrm>
+            <a:off x="457200" y="969264"/>
+            <a:ext cx="8229600" cy="274320"/>
+          </a:xfrm>
+          <a:prstGeom prst="rect">
+            <a:avLst/>
+          </a:prstGeom>
+          <a:noFill/>
+          <a:ln/>
+        </p:spPr>
+        <p:txBody>
+          <a:bodyPr wrap="square" lIns="0" tIns="0" rIns="0" bIns="0" rtlCol="0" anchor="ctr"/>
+          <a:lstStyle/>
+          <a:p>
+            <a:pPr marL="0" marR="0" lvl="0" indent="0" algn="l" defTabSz="914400" rtl="0" eaLnBrk="1" fontAlgn="auto" latinLnBrk="0" hangingPunct="1">
+              <a:lnSpc>
+                <a:spcPct val="100000"/>
+              </a:lnSpc>
+              <a:spcBef>
+                <a:spcPts val="0"/>
+              </a:spcBef>
+              <a:spcAft>
+                <a:spcPts val="0"/>
+              </a:spcAft>
+              <a:buClrTx/>
+              <a:buSzTx/>
+              <a:buFontTx/>
+              <a:buNone/>
+              <a:tabLst/>
+              <a:defRPr/>
+            </a:pPr>
+            <a:r>
+              <a:rPr kumimoji="0" lang="en-US" sz="1050" b="0" i="1" u="none" strike="noStrike" kern="1200" cap="none" spc="0" normalizeH="0" baseline="0" noProof="0" dirty="0">
+                <a:ln>
+                  <a:noFill/>
+                </a:ln>
+                <a:solidFill>
+                  <a:srgbClr val="AAB4C4"/>
+                </a:solidFill>
+                <a:effectLst/>
+                <a:uLnTx/>
+                <a:uFillTx/>
+                <a:latin typeface="Calibri" pitchFamily="34" charset="0"/>
+                <a:ea typeface="Calibri" pitchFamily="34" charset="-122"/>
+                <a:cs typeface="Calibri" pitchFamily="34" charset="-120"/>
+              </a:rPr>
+              <a:t>Every EY coding principle mapped to what we actually built and shipped on the Credit Risk Intelligence Platform.</a:t>
+            </a:r>
+            <a:endParaRPr kumimoji="0" lang="en-US" sz="1050" b="0" i="0" u="none" strike="noStrike" kern="1200" cap="none" spc="0" normalizeH="0" baseline="0" noProof="0" dirty="0">
+              <a:ln>
+                <a:noFill/>
+              </a:ln>
+              <a:solidFill>
+                <a:prstClr val="black"/>
+              </a:solidFill>
+              <a:effectLst/>
+              <a:uLnTx/>
+              <a:uFillTx/>
+              <a:latin typeface="Calibri" panose="020F0502020204030204"/>
+              <a:ea typeface="+mn-ea"/>
+              <a:cs typeface="+mn-cs"/>
+            </a:endParaRPr>
+          </a:p>
+        </p:txBody>
+      </p:sp>
+      <p:sp>
+        <p:nvSpPr>
+          <p:cNvPr id="6" name="Shape 4"/>
+          <p:cNvSpPr/>
+          <p:nvPr/>
+        </p:nvSpPr>
+        <p:spPr>
+          <a:xfrm>
+            <a:off x="457200" y="1417320"/>
+            <a:ext cx="3977640" cy="841248"/>
           </a:xfrm>
           <a:prstGeom prst="roundRect">
             <a:avLst>
-              <a:gd name="adj" fmla="val 12903"/>
+              <a:gd name="adj" fmla="val 6522"/>
             </a:avLst>
           </a:prstGeom>
           <a:solidFill>
             <a:srgbClr val="162032"/>
           </a:solidFill>
-          <a:ln/>
+          <a:ln w="9525">
+            <a:solidFill>
+              <a:srgbClr val="233047"/>
+            </a:solidFill>
+            <a:prstDash val="solid"/>
+          </a:ln>
           <a:effectLst>
-            <a:outerShdw blurRad="50800" dist="25400" dir="2700000" algn="bl" rotWithShape="0">
+            <a:outerShdw blurRad="76200" dist="25400" dir="5400000" algn="bl" rotWithShape="0">
               <a:srgbClr val="000000">
-                <a:alpha val="12000"/>
+                <a:alpha val="16000"/>
               </a:srgbClr>
             </a:outerShdw>
           </a:effectLst>
@@ -13964,14 +14211,108 @@
       </p:sp>
       <p:sp>
         <p:nvSpPr>
+          <p:cNvPr id="7" name="Shape 5"/>
+          <p:cNvSpPr/>
+          <p:nvPr/>
+        </p:nvSpPr>
+        <p:spPr>
+          <a:xfrm>
+            <a:off x="603504" y="1545336"/>
+            <a:ext cx="402336" cy="402336"/>
+          </a:xfrm>
+          <a:prstGeom prst="ellipse">
+            <a:avLst/>
+          </a:prstGeom>
+          <a:solidFill>
+            <a:srgbClr val="E8544E">
+              <a:alpha val="20000"/>
+            </a:srgbClr>
+          </a:solidFill>
+          <a:ln/>
+        </p:spPr>
+      </p:sp>
+      <p:sp>
+        <p:nvSpPr>
+          <p:cNvPr id="8" name="Text 6"/>
+          <p:cNvSpPr/>
+          <p:nvPr/>
+        </p:nvSpPr>
+        <p:spPr>
+          <a:xfrm>
+            <a:off x="603504" y="1545336"/>
+            <a:ext cx="402336" cy="402336"/>
+          </a:xfrm>
+          <a:prstGeom prst="rect">
+            <a:avLst/>
+          </a:prstGeom>
+          <a:noFill/>
+          <a:ln/>
+        </p:spPr>
+        <p:txBody>
+          <a:bodyPr wrap="square" lIns="0" tIns="0" rIns="0" bIns="0" rtlCol="0" anchor="ctr"/>
+          <a:lstStyle/>
+          <a:p>
+            <a:pPr marL="0" marR="0" lvl="0" indent="0" algn="ctr" defTabSz="914400" rtl="0" eaLnBrk="1" fontAlgn="auto" latinLnBrk="0" hangingPunct="1">
+              <a:lnSpc>
+                <a:spcPct val="100000"/>
+              </a:lnSpc>
+              <a:spcBef>
+                <a:spcPts val="0"/>
+              </a:spcBef>
+              <a:spcAft>
+                <a:spcPts val="0"/>
+              </a:spcAft>
+              <a:buClrTx/>
+              <a:buSzTx/>
+              <a:buFontTx/>
+              <a:buNone/>
+              <a:tabLst/>
+              <a:defRPr/>
+            </a:pPr>
+            <a:r>
+              <a:rPr kumimoji="0" lang="en-US" sz="1400" b="0" i="0" u="none" strike="noStrike" kern="1200" cap="none" spc="0" normalizeH="0" baseline="0" noProof="0" dirty="0">
+                <a:ln>
+                  <a:noFill/>
+                </a:ln>
+                <a:solidFill>
+                  <a:srgbClr val="E8544E"/>
+                </a:solidFill>
+                <a:effectLst/>
+                <a:uLnTx/>
+                <a:uFillTx/>
+                <a:latin typeface="Calibri" panose="020F0502020204030204"/>
+                <a:ea typeface="+mn-ea"/>
+                <a:cs typeface="+mn-cs"/>
+              </a:rPr>
+              <a:t>✎</a:t>
+            </a:r>
+            <a:endParaRPr kumimoji="0" lang="en-US" sz="1400" b="0" i="0" u="none" strike="noStrike" kern="1200" cap="none" spc="0" normalizeH="0" baseline="0" noProof="0" dirty="0">
+              <a:ln>
+                <a:noFill/>
+              </a:ln>
+              <a:solidFill>
+                <a:prstClr val="black"/>
+              </a:solidFill>
+              <a:effectLst/>
+              <a:uLnTx/>
+              <a:uFillTx/>
+              <a:latin typeface="Calibri" panose="020F0502020204030204"/>
+              <a:ea typeface="+mn-ea"/>
+              <a:cs typeface="+mn-cs"/>
+            </a:endParaRPr>
+          </a:p>
+        </p:txBody>
+      </p:sp>
+      <p:sp>
+        <p:nvSpPr>
           <p:cNvPr id="9" name="Text 7"/>
           <p:cNvSpPr/>
           <p:nvPr/>
         </p:nvSpPr>
         <p:spPr>
           <a:xfrm>
-            <a:off x="1005840" y="2487168"/>
-            <a:ext cx="1097280" cy="384048"/>
+            <a:off x="1115568" y="1508760"/>
+            <a:ext cx="3172968" cy="219456"/>
           </a:xfrm>
           <a:prstGeom prst="rect">
             <a:avLst/>
@@ -13983,18 +14324,54 @@
           <a:bodyPr wrap="square" lIns="0" tIns="0" rIns="0" bIns="0" rtlCol="0" anchor="ctr"/>
           <a:lstStyle/>
           <a:p>
-            <a:pPr marL="0" indent="0">
-              <a:buNone/>
-            </a:pPr>
-            <a:r>
-              <a:rPr lang="en-US" sz="1000" b="1" dirty="0">
-                <a:solidFill>
-                  <a:srgbClr val="0891B2"/>
-                </a:solidFill>
-              </a:rPr>
-              <a:t>🌐 Live App  </a:t>
-            </a:r>
-            <a:endParaRPr lang="en-US" sz="1000" dirty="0"/>
+            <a:pPr marL="0" marR="0" lvl="0" indent="0" algn="l" defTabSz="914400" rtl="0" eaLnBrk="1" fontAlgn="auto" latinLnBrk="0" hangingPunct="1">
+              <a:lnSpc>
+                <a:spcPct val="100000"/>
+              </a:lnSpc>
+              <a:spcBef>
+                <a:spcPts val="0"/>
+              </a:spcBef>
+              <a:spcAft>
+                <a:spcPts val="0"/>
+              </a:spcAft>
+              <a:buClrTx/>
+              <a:buSzTx/>
+              <a:buFontTx/>
+              <a:buNone/>
+              <a:tabLst/>
+              <a:defRPr/>
+            </a:pPr>
+            <a:r>
+              <a:rPr kumimoji="0" lang="en-US" sz="1200" b="1" i="0" u="none" strike="noStrike" kern="1200" cap="none" spc="0" normalizeH="0" baseline="0" noProof="0" dirty="0">
+                <a:ln>
+                  <a:noFill/>
+                </a:ln>
+                <a:solidFill>
+                  <a:srgbClr val="FFFFFF"/>
+                </a:solidFill>
+                <a:effectLst/>
+                <a:uLnTx/>
+                <a:uFillTx/>
+                <a:latin typeface="Cambria" pitchFamily="34" charset="0"/>
+                <a:ea typeface="Cambria" pitchFamily="34" charset="-122"/>
+                <a:cs typeface="Cambria" pitchFamily="34" charset="-120"/>
+              </a:rPr>
+              <a:t>Naming Conventions</a:t>
+            </a:r>
+            <a:endParaRPr kumimoji="0" lang="en-US" sz="1200" b="0" i="0" u="none" strike="noStrike" kern="1200" cap="none" spc="0" normalizeH="0" baseline="0" noProof="0" dirty="0">
+              <a:ln>
+                <a:noFill/>
+              </a:ln>
+              <a:solidFill>
+                <a:prstClr val="black"/>
+              </a:solidFill>
+              <a:effectLst/>
+              <a:uLnTx/>
+              <a:uFillTx/>
+              <a:latin typeface="Calibri" panose="020F0502020204030204"/>
+              <a:ea typeface="+mn-ea"/>
+              <a:cs typeface="+mn-cs"/>
+            </a:endParaRPr>
           </a:p>
         </p:txBody>
       </p:sp>
@@ -14006,34 +14383,67 @@
         </p:nvSpPr>
         <p:spPr>
           <a:xfrm>
-            <a:off x="1920240" y="2487168"/>
-            <a:ext cx="2286000" cy="384048"/>
-          </a:xfrm>
-          <a:prstGeom prst="rect">
-            <a:avLst/>
-          </a:prstGeom>
-          <a:noFill/>
-          <a:ln/>
-        </p:spPr>
-        <p:txBody>
-          <a:bodyPr wrap="square" lIns="0" tIns="0" rIns="0" bIns="0" rtlCol="0" anchor="ctr"/>
-          <a:lstStyle/>
-          <a:p>
-            <a:pPr marL="0" indent="0">
-              <a:buNone/>
-            </a:pPr>
-            <a:r>
-              <a:rPr lang="en-US" sz="950" dirty="0">
-                <a:solidFill>
-                  <a:srgbClr val="FFFFFF"/>
-                </a:solidFill>
-                <a:latin typeface="Courier New" pitchFamily="34" charset="0"/>
-                <a:ea typeface="Courier New" pitchFamily="34" charset="-122"/>
-                <a:cs typeface="Courier New" pitchFamily="34" charset="-120"/>
-              </a:rPr>
-              <a:t>creditriskplatform.azurewebsites.net</a:t>
-            </a:r>
-            <a:endParaRPr lang="en-US" sz="950" dirty="0"/>
+            <a:off x="1115568" y="1728216"/>
+            <a:ext cx="3172968" cy="457200"/>
+          </a:xfrm>
+          <a:prstGeom prst="rect">
+            <a:avLst/>
+          </a:prstGeom>
+          <a:noFill/>
+          <a:ln/>
+        </p:spPr>
+        <p:txBody>
+          <a:bodyPr wrap="square" lIns="0" tIns="0" rIns="0" bIns="0" rtlCol="0" anchor="t"/>
+          <a:lstStyle/>
+          <a:p>
+            <a:pPr marL="0" marR="0" lvl="0" indent="0" algn="l" defTabSz="914400" rtl="0" eaLnBrk="1" fontAlgn="auto" latinLnBrk="0" hangingPunct="1">
+              <a:lnSpc>
+                <a:spcPct val="108000"/>
+              </a:lnSpc>
+              <a:spcBef>
+                <a:spcPts val="0"/>
+              </a:spcBef>
+              <a:spcAft>
+                <a:spcPts val="0"/>
+              </a:spcAft>
+              <a:buClrTx/>
+              <a:buSzTx/>
+              <a:buFontTx/>
+              <a:buNone/>
+              <a:tabLst/>
+              <a:defRPr/>
+            </a:pPr>
+            <a:r>
+              <a:rPr kumimoji="0" lang="en-US" sz="870" b="0" i="0" u="none" strike="noStrike" kern="1200" cap="none" spc="0" normalizeH="0" baseline="0" noProof="0" dirty="0">
+                <a:ln>
+                  <a:noFill/>
+                </a:ln>
+                <a:solidFill>
+                  <a:srgbClr val="AAB4C4"/>
+                </a:solidFill>
+                <a:effectLst/>
+                <a:uLnTx/>
+                <a:uFillTx/>
+                <a:latin typeface="Calibri" pitchFamily="34" charset="0"/>
+                <a:ea typeface="Calibri" pitchFamily="34" charset="-122"/>
+                <a:cs typeface="Calibri" pitchFamily="34" charset="-120"/>
+              </a:rPr>
+              <a:t>Modules named by responsibility — test_auth.py, test_loan_workflow.py, test_reranker.py, retrieval_agent, chat_agent — consistent across the codebase.</a:t>
+            </a:r>
+            <a:endParaRPr kumimoji="0" lang="en-US" sz="870" b="0" i="0" u="none" strike="noStrike" kern="1200" cap="none" spc="0" normalizeH="0" baseline="0" noProof="0" dirty="0">
+              <a:ln>
+                <a:noFill/>
+              </a:ln>
+              <a:solidFill>
+                <a:prstClr val="black"/>
+              </a:solidFill>
+              <a:effectLst/>
+              <a:uLnTx/>
+              <a:uFillTx/>
+              <a:latin typeface="Calibri" panose="020F0502020204030204"/>
+              <a:ea typeface="+mn-ea"/>
+              <a:cs typeface="+mn-cs"/>
+            </a:endParaRPr>
           </a:p>
         </p:txBody>
       </p:sp>
@@ -14045,22 +14455,27 @@
         </p:nvSpPr>
         <p:spPr>
           <a:xfrm>
-            <a:off x="4663440" y="2423160"/>
-            <a:ext cx="3520440" cy="566928"/>
+            <a:off x="4709160" y="1417320"/>
+            <a:ext cx="3977640" cy="841248"/>
           </a:xfrm>
           <a:prstGeom prst="roundRect">
             <a:avLst>
-              <a:gd name="adj" fmla="val 12903"/>
+              <a:gd name="adj" fmla="val 6522"/>
             </a:avLst>
           </a:prstGeom>
           <a:solidFill>
             <a:srgbClr val="162032"/>
           </a:solidFill>
-          <a:ln/>
+          <a:ln w="9525">
+            <a:solidFill>
+              <a:srgbClr val="233047"/>
+            </a:solidFill>
+            <a:prstDash val="solid"/>
+          </a:ln>
           <a:effectLst>
-            <a:outerShdw blurRad="50800" dist="25400" dir="2700000" algn="bl" rotWithShape="0">
+            <a:outerShdw blurRad="76200" dist="25400" dir="5400000" algn="bl" rotWithShape="0">
               <a:srgbClr val="000000">
-                <a:alpha val="12000"/>
+                <a:alpha val="16000"/>
               </a:srgbClr>
             </a:outerShdw>
           </a:effectLst>
@@ -14068,14 +14483,36 @@
       </p:sp>
       <p:sp>
         <p:nvSpPr>
-          <p:cNvPr id="12" name="Text 10"/>
-          <p:cNvSpPr/>
-          <p:nvPr/>
-        </p:nvSpPr>
-        <p:spPr>
-          <a:xfrm>
-            <a:off x="4846320" y="2487168"/>
-            <a:ext cx="1097280" cy="384048"/>
+          <p:cNvPr id="12" name="Shape 10"/>
+          <p:cNvSpPr/>
+          <p:nvPr/>
+        </p:nvSpPr>
+        <p:spPr>
+          <a:xfrm>
+            <a:off x="4855464" y="1545336"/>
+            <a:ext cx="402336" cy="402336"/>
+          </a:xfrm>
+          <a:prstGeom prst="ellipse">
+            <a:avLst/>
+          </a:prstGeom>
+          <a:solidFill>
+            <a:srgbClr val="3B82F6">
+              <a:alpha val="20000"/>
+            </a:srgbClr>
+          </a:solidFill>
+          <a:ln/>
+        </p:spPr>
+      </p:sp>
+      <p:sp>
+        <p:nvSpPr>
+          <p:cNvPr id="13" name="Text 11"/>
+          <p:cNvSpPr/>
+          <p:nvPr/>
+        </p:nvSpPr>
+        <p:spPr>
+          <a:xfrm>
+            <a:off x="4855464" y="1545336"/>
+            <a:ext cx="402336" cy="402336"/>
           </a:xfrm>
           <a:prstGeom prst="rect">
             <a:avLst/>
@@ -14087,31 +14524,67 @@
           <a:bodyPr wrap="square" lIns="0" tIns="0" rIns="0" bIns="0" rtlCol="0" anchor="ctr"/>
           <a:lstStyle/>
           <a:p>
-            <a:pPr marL="0" indent="0">
-              <a:buNone/>
-            </a:pPr>
-            <a:r>
-              <a:rPr lang="en-US" sz="1000" b="1" dirty="0">
-                <a:solidFill>
-                  <a:srgbClr val="2563EB"/>
-                </a:solidFill>
-              </a:rPr>
-              <a:t>💻 GitHub  </a:t>
-            </a:r>
-            <a:endParaRPr lang="en-US" sz="1000" dirty="0"/>
-          </a:p>
-        </p:txBody>
-      </p:sp>
-      <p:sp>
-        <p:nvSpPr>
-          <p:cNvPr id="13" name="Text 11"/>
-          <p:cNvSpPr/>
-          <p:nvPr/>
-        </p:nvSpPr>
-        <p:spPr>
-          <a:xfrm>
-            <a:off x="5760720" y="2487168"/>
-            <a:ext cx="2286000" cy="384048"/>
+            <a:pPr marL="0" marR="0" lvl="0" indent="0" algn="ctr" defTabSz="914400" rtl="0" eaLnBrk="1" fontAlgn="auto" latinLnBrk="0" hangingPunct="1">
+              <a:lnSpc>
+                <a:spcPct val="100000"/>
+              </a:lnSpc>
+              <a:spcBef>
+                <a:spcPts val="0"/>
+              </a:spcBef>
+              <a:spcAft>
+                <a:spcPts val="0"/>
+              </a:spcAft>
+              <a:buClrTx/>
+              <a:buSzTx/>
+              <a:buFontTx/>
+              <a:buNone/>
+              <a:tabLst/>
+              <a:defRPr/>
+            </a:pPr>
+            <a:r>
+              <a:rPr kumimoji="0" lang="en-US" sz="1400" b="0" i="0" u="none" strike="noStrike" kern="1200" cap="none" spc="0" normalizeH="0" baseline="0" noProof="0" dirty="0">
+                <a:ln>
+                  <a:noFill/>
+                </a:ln>
+                <a:solidFill>
+                  <a:srgbClr val="3B82F6"/>
+                </a:solidFill>
+                <a:effectLst/>
+                <a:uLnTx/>
+                <a:uFillTx/>
+                <a:latin typeface="Calibri" panose="020F0502020204030204"/>
+                <a:ea typeface="+mn-ea"/>
+                <a:cs typeface="+mn-cs"/>
+              </a:rPr>
+              <a:t>🔀</a:t>
+            </a:r>
+            <a:endParaRPr kumimoji="0" lang="en-US" sz="1400" b="0" i="0" u="none" strike="noStrike" kern="1200" cap="none" spc="0" normalizeH="0" baseline="0" noProof="0" dirty="0">
+              <a:ln>
+                <a:noFill/>
+              </a:ln>
+              <a:solidFill>
+                <a:prstClr val="black"/>
+              </a:solidFill>
+              <a:effectLst/>
+              <a:uLnTx/>
+              <a:uFillTx/>
+              <a:latin typeface="Calibri" panose="020F0502020204030204"/>
+              <a:ea typeface="+mn-ea"/>
+              <a:cs typeface="+mn-cs"/>
+            </a:endParaRPr>
+          </a:p>
+        </p:txBody>
+      </p:sp>
+      <p:sp>
+        <p:nvSpPr>
+          <p:cNvPr id="14" name="Text 12"/>
+          <p:cNvSpPr/>
+          <p:nvPr/>
+        </p:nvSpPr>
+        <p:spPr>
+          <a:xfrm>
+            <a:off x="5367528" y="1508760"/>
+            <a:ext cx="3172968" cy="219456"/>
           </a:xfrm>
           <a:prstGeom prst="rect">
             <a:avLst/>
@@ -14123,48 +14596,158 @@
           <a:bodyPr wrap="square" lIns="0" tIns="0" rIns="0" bIns="0" rtlCol="0" anchor="ctr"/>
           <a:lstStyle/>
           <a:p>
-            <a:pPr marL="0" indent="0">
-              <a:buNone/>
-            </a:pPr>
-            <a:r>
-              <a:rPr lang="en-US" sz="950" dirty="0">
+            <a:pPr marL="0" marR="0" lvl="0" indent="0" algn="l" defTabSz="914400" rtl="0" eaLnBrk="1" fontAlgn="auto" latinLnBrk="0" hangingPunct="1">
+              <a:lnSpc>
+                <a:spcPct val="100000"/>
+              </a:lnSpc>
+              <a:spcBef>
+                <a:spcPts val="0"/>
+              </a:spcBef>
+              <a:spcAft>
+                <a:spcPts val="0"/>
+              </a:spcAft>
+              <a:buClrTx/>
+              <a:buSzTx/>
+              <a:buFontTx/>
+              <a:buNone/>
+              <a:tabLst/>
+              <a:defRPr/>
+            </a:pPr>
+            <a:r>
+              <a:rPr kumimoji="0" lang="en-US" sz="1200" b="1" i="0" u="none" strike="noStrike" kern="1200" cap="none" spc="0" normalizeH="0" baseline="0" noProof="0" dirty="0">
+                <a:ln>
+                  <a:noFill/>
+                </a:ln>
                 <a:solidFill>
                   <a:srgbClr val="FFFFFF"/>
                 </a:solidFill>
-                <a:latin typeface="Courier New" pitchFamily="34" charset="0"/>
-                <a:ea typeface="Courier New" pitchFamily="34" charset="-122"/>
-                <a:cs typeface="Courier New" pitchFamily="34" charset="-120"/>
-              </a:rPr>
-              <a:t>github.com/Chaurasiyakash0136/EY-Training-2026</a:t>
-            </a:r>
-            <a:endParaRPr lang="en-US" sz="950" dirty="0"/>
-          </a:p>
-        </p:txBody>
-      </p:sp>
-      <p:sp>
-        <p:nvSpPr>
-          <p:cNvPr id="14" name="Shape 12"/>
-          <p:cNvSpPr/>
-          <p:nvPr/>
-        </p:nvSpPr>
-        <p:spPr>
-          <a:xfrm>
-            <a:off x="822960" y="3136392"/>
-            <a:ext cx="3520440" cy="566928"/>
+                <a:effectLst/>
+                <a:uLnTx/>
+                <a:uFillTx/>
+                <a:latin typeface="Cambria" pitchFamily="34" charset="0"/>
+                <a:ea typeface="Cambria" pitchFamily="34" charset="-122"/>
+                <a:cs typeface="Cambria" pitchFamily="34" charset="-120"/>
+              </a:rPr>
+              <a:t>Code Reviews</a:t>
+            </a:r>
+            <a:endParaRPr kumimoji="0" lang="en-US" sz="1200" b="0" i="0" u="none" strike="noStrike" kern="1200" cap="none" spc="0" normalizeH="0" baseline="0" noProof="0" dirty="0">
+              <a:ln>
+                <a:noFill/>
+              </a:ln>
+              <a:solidFill>
+                <a:prstClr val="black"/>
+              </a:solidFill>
+              <a:effectLst/>
+              <a:uLnTx/>
+              <a:uFillTx/>
+              <a:latin typeface="Calibri" panose="020F0502020204030204"/>
+              <a:ea typeface="+mn-ea"/>
+              <a:cs typeface="+mn-cs"/>
+            </a:endParaRPr>
+          </a:p>
+        </p:txBody>
+      </p:sp>
+      <p:sp>
+        <p:nvSpPr>
+          <p:cNvPr id="15" name="Text 13"/>
+          <p:cNvSpPr/>
+          <p:nvPr/>
+        </p:nvSpPr>
+        <p:spPr>
+          <a:xfrm>
+            <a:off x="5367528" y="1728216"/>
+            <a:ext cx="3172968" cy="457200"/>
+          </a:xfrm>
+          <a:prstGeom prst="rect">
+            <a:avLst/>
+          </a:prstGeom>
+          <a:noFill/>
+          <a:ln/>
+        </p:spPr>
+        <p:txBody>
+          <a:bodyPr wrap="square" lIns="0" tIns="0" rIns="0" bIns="0" rtlCol="0" anchor="t"/>
+          <a:lstStyle/>
+          <a:p>
+            <a:pPr marL="0" marR="0" lvl="0" indent="0" algn="l" defTabSz="914400" rtl="0" eaLnBrk="1" fontAlgn="auto" latinLnBrk="0" hangingPunct="1">
+              <a:lnSpc>
+                <a:spcPct val="108000"/>
+              </a:lnSpc>
+              <a:spcBef>
+                <a:spcPts val="0"/>
+              </a:spcBef>
+              <a:spcAft>
+                <a:spcPts val="0"/>
+              </a:spcAft>
+              <a:buClrTx/>
+              <a:buSzTx/>
+              <a:buFontTx/>
+              <a:buNone/>
+              <a:tabLst/>
+              <a:defRPr/>
+            </a:pPr>
+            <a:r>
+              <a:rPr kumimoji="0" lang="en-US" sz="870" b="0" i="0" u="none" strike="noStrike" kern="1200" cap="none" spc="0" normalizeH="0" baseline="0" noProof="0" dirty="0">
+                <a:ln>
+                  <a:noFill/>
+                </a:ln>
+                <a:solidFill>
+                  <a:srgbClr val="AAB4C4"/>
+                </a:solidFill>
+                <a:effectLst/>
+                <a:uLnTx/>
+                <a:uFillTx/>
+                <a:latin typeface="Calibri" pitchFamily="34" charset="0"/>
+                <a:ea typeface="Calibri" pitchFamily="34" charset="-122"/>
+                <a:cs typeface="Calibri" pitchFamily="34" charset="-120"/>
+              </a:rPr>
+              <a:t>Every push is gated: GitHub Actions runs all 96 tests automatically before code can move forward — no merge without a passing check.</a:t>
+            </a:r>
+            <a:endParaRPr kumimoji="0" lang="en-US" sz="870" b="0" i="0" u="none" strike="noStrike" kern="1200" cap="none" spc="0" normalizeH="0" baseline="0" noProof="0" dirty="0">
+              <a:ln>
+                <a:noFill/>
+              </a:ln>
+              <a:solidFill>
+                <a:prstClr val="black"/>
+              </a:solidFill>
+              <a:effectLst/>
+              <a:uLnTx/>
+              <a:uFillTx/>
+              <a:latin typeface="Calibri" panose="020F0502020204030204"/>
+              <a:ea typeface="+mn-ea"/>
+              <a:cs typeface="+mn-cs"/>
+            </a:endParaRPr>
+          </a:p>
+        </p:txBody>
+      </p:sp>
+      <p:sp>
+        <p:nvSpPr>
+          <p:cNvPr id="16" name="Shape 14"/>
+          <p:cNvSpPr/>
+          <p:nvPr/>
+        </p:nvSpPr>
+        <p:spPr>
+          <a:xfrm>
+            <a:off x="457200" y="2331720"/>
+            <a:ext cx="3977640" cy="841248"/>
           </a:xfrm>
           <a:prstGeom prst="roundRect">
             <a:avLst>
-              <a:gd name="adj" fmla="val 12903"/>
+              <a:gd name="adj" fmla="val 6522"/>
             </a:avLst>
           </a:prstGeom>
           <a:solidFill>
             <a:srgbClr val="162032"/>
           </a:solidFill>
-          <a:ln/>
+          <a:ln w="9525">
+            <a:solidFill>
+              <a:srgbClr val="233047"/>
+            </a:solidFill>
+            <a:prstDash val="solid"/>
+          </a:ln>
           <a:effectLst>
-            <a:outerShdw blurRad="50800" dist="25400" dir="2700000" algn="bl" rotWithShape="0">
+            <a:outerShdw blurRad="76200" dist="25400" dir="5400000" algn="bl" rotWithShape="0">
               <a:srgbClr val="000000">
-                <a:alpha val="12000"/>
+                <a:alpha val="16000"/>
               </a:srgbClr>
             </a:outerShdw>
           </a:effectLst>
@@ -14172,14 +14755,36 @@
       </p:sp>
       <p:sp>
         <p:nvSpPr>
-          <p:cNvPr id="15" name="Text 13"/>
-          <p:cNvSpPr/>
-          <p:nvPr/>
-        </p:nvSpPr>
-        <p:spPr>
-          <a:xfrm>
-            <a:off x="1005840" y="3200400"/>
-            <a:ext cx="1097280" cy="384048"/>
+          <p:cNvPr id="17" name="Shape 15"/>
+          <p:cNvSpPr/>
+          <p:nvPr/>
+        </p:nvSpPr>
+        <p:spPr>
+          <a:xfrm>
+            <a:off x="603504" y="2459736"/>
+            <a:ext cx="402336" cy="402336"/>
+          </a:xfrm>
+          <a:prstGeom prst="ellipse">
+            <a:avLst/>
+          </a:prstGeom>
+          <a:solidFill>
+            <a:srgbClr val="059669">
+              <a:alpha val="20000"/>
+            </a:srgbClr>
+          </a:solidFill>
+          <a:ln/>
+        </p:spPr>
+      </p:sp>
+      <p:sp>
+        <p:nvSpPr>
+          <p:cNvPr id="18" name="Text 16"/>
+          <p:cNvSpPr/>
+          <p:nvPr/>
+        </p:nvSpPr>
+        <p:spPr>
+          <a:xfrm>
+            <a:off x="603504" y="2459736"/>
+            <a:ext cx="402336" cy="402336"/>
           </a:xfrm>
           <a:prstGeom prst="rect">
             <a:avLst/>
@@ -14191,31 +14796,67 @@
           <a:bodyPr wrap="square" lIns="0" tIns="0" rIns="0" bIns="0" rtlCol="0" anchor="ctr"/>
           <a:lstStyle/>
           <a:p>
-            <a:pPr marL="0" indent="0">
-              <a:buNone/>
-            </a:pPr>
-            <a:r>
-              <a:rPr lang="en-US" sz="1000" b="1" dirty="0">
-                <a:solidFill>
-                  <a:srgbClr val="D97706"/>
-                </a:solidFill>
-              </a:rPr>
-              <a:t>🔍 LangSmith  </a:t>
-            </a:r>
-            <a:endParaRPr lang="en-US" sz="1000" dirty="0"/>
-          </a:p>
-        </p:txBody>
-      </p:sp>
-      <p:sp>
-        <p:nvSpPr>
-          <p:cNvPr id="16" name="Text 14"/>
-          <p:cNvSpPr/>
-          <p:nvPr/>
-        </p:nvSpPr>
-        <p:spPr>
-          <a:xfrm>
-            <a:off x="1920240" y="3200400"/>
-            <a:ext cx="2286000" cy="384048"/>
+            <a:pPr marL="0" marR="0" lvl="0" indent="0" algn="ctr" defTabSz="914400" rtl="0" eaLnBrk="1" fontAlgn="auto" latinLnBrk="0" hangingPunct="1">
+              <a:lnSpc>
+                <a:spcPct val="100000"/>
+              </a:lnSpc>
+              <a:spcBef>
+                <a:spcPts val="0"/>
+              </a:spcBef>
+              <a:spcAft>
+                <a:spcPts val="0"/>
+              </a:spcAft>
+              <a:buClrTx/>
+              <a:buSzTx/>
+              <a:buFontTx/>
+              <a:buNone/>
+              <a:tabLst/>
+              <a:defRPr/>
+            </a:pPr>
+            <a:r>
+              <a:rPr kumimoji="0" lang="en-US" sz="1400" b="0" i="0" u="none" strike="noStrike" kern="1200" cap="none" spc="0" normalizeH="0" baseline="0" noProof="0" dirty="0">
+                <a:ln>
+                  <a:noFill/>
+                </a:ln>
+                <a:solidFill>
+                  <a:srgbClr val="059669"/>
+                </a:solidFill>
+                <a:effectLst/>
+                <a:uLnTx/>
+                <a:uFillTx/>
+                <a:latin typeface="Calibri" panose="020F0502020204030204"/>
+                <a:ea typeface="+mn-ea"/>
+                <a:cs typeface="+mn-cs"/>
+              </a:rPr>
+              <a:t>📄</a:t>
+            </a:r>
+            <a:endParaRPr kumimoji="0" lang="en-US" sz="1400" b="0" i="0" u="none" strike="noStrike" kern="1200" cap="none" spc="0" normalizeH="0" baseline="0" noProof="0" dirty="0">
+              <a:ln>
+                <a:noFill/>
+              </a:ln>
+              <a:solidFill>
+                <a:prstClr val="black"/>
+              </a:solidFill>
+              <a:effectLst/>
+              <a:uLnTx/>
+              <a:uFillTx/>
+              <a:latin typeface="Calibri" panose="020F0502020204030204"/>
+              <a:ea typeface="+mn-ea"/>
+              <a:cs typeface="+mn-cs"/>
+            </a:endParaRPr>
+          </a:p>
+        </p:txBody>
+      </p:sp>
+      <p:sp>
+        <p:nvSpPr>
+          <p:cNvPr id="19" name="Text 17"/>
+          <p:cNvSpPr/>
+          <p:nvPr/>
+        </p:nvSpPr>
+        <p:spPr>
+          <a:xfrm>
+            <a:off x="1115568" y="2423160"/>
+            <a:ext cx="3172968" cy="219456"/>
           </a:xfrm>
           <a:prstGeom prst="rect">
             <a:avLst/>
@@ -14227,48 +14868,158 @@
           <a:bodyPr wrap="square" lIns="0" tIns="0" rIns="0" bIns="0" rtlCol="0" anchor="ctr"/>
           <a:lstStyle/>
           <a:p>
-            <a:pPr marL="0" indent="0">
-              <a:buNone/>
-            </a:pPr>
-            <a:r>
-              <a:rPr lang="en-US" sz="950" dirty="0">
+            <a:pPr marL="0" marR="0" lvl="0" indent="0" algn="l" defTabSz="914400" rtl="0" eaLnBrk="1" fontAlgn="auto" latinLnBrk="0" hangingPunct="1">
+              <a:lnSpc>
+                <a:spcPct val="100000"/>
+              </a:lnSpc>
+              <a:spcBef>
+                <a:spcPts val="0"/>
+              </a:spcBef>
+              <a:spcAft>
+                <a:spcPts val="0"/>
+              </a:spcAft>
+              <a:buClrTx/>
+              <a:buSzTx/>
+              <a:buFontTx/>
+              <a:buNone/>
+              <a:tabLst/>
+              <a:defRPr/>
+            </a:pPr>
+            <a:r>
+              <a:rPr kumimoji="0" lang="en-US" sz="1200" b="1" i="0" u="none" strike="noStrike" kern="1200" cap="none" spc="0" normalizeH="0" baseline="0" noProof="0" dirty="0">
+                <a:ln>
+                  <a:noFill/>
+                </a:ln>
                 <a:solidFill>
                   <a:srgbClr val="FFFFFF"/>
                 </a:solidFill>
-                <a:latin typeface="Courier New" pitchFamily="34" charset="0"/>
-                <a:ea typeface="Courier New" pitchFamily="34" charset="-122"/>
-                <a:cs typeface="Courier New" pitchFamily="34" charset="-120"/>
-              </a:rPr>
-              <a:t>smith.langchain.com → credit-risk-platform</a:t>
-            </a:r>
-            <a:endParaRPr lang="en-US" sz="950" dirty="0"/>
-          </a:p>
-        </p:txBody>
-      </p:sp>
-      <p:sp>
-        <p:nvSpPr>
-          <p:cNvPr id="17" name="Shape 15"/>
-          <p:cNvSpPr/>
-          <p:nvPr/>
-        </p:nvSpPr>
-        <p:spPr>
-          <a:xfrm>
-            <a:off x="4663440" y="3136392"/>
-            <a:ext cx="3520440" cy="566928"/>
+                <a:effectLst/>
+                <a:uLnTx/>
+                <a:uFillTx/>
+                <a:latin typeface="Cambria" pitchFamily="34" charset="0"/>
+                <a:ea typeface="Cambria" pitchFamily="34" charset="-122"/>
+                <a:cs typeface="Cambria" pitchFamily="34" charset="-120"/>
+              </a:rPr>
+              <a:t>Documentation</a:t>
+            </a:r>
+            <a:endParaRPr kumimoji="0" lang="en-US" sz="1200" b="0" i="0" u="none" strike="noStrike" kern="1200" cap="none" spc="0" normalizeH="0" baseline="0" noProof="0" dirty="0">
+              <a:ln>
+                <a:noFill/>
+              </a:ln>
+              <a:solidFill>
+                <a:prstClr val="black"/>
+              </a:solidFill>
+              <a:effectLst/>
+              <a:uLnTx/>
+              <a:uFillTx/>
+              <a:latin typeface="Calibri" panose="020F0502020204030204"/>
+              <a:ea typeface="+mn-ea"/>
+              <a:cs typeface="+mn-cs"/>
+            </a:endParaRPr>
+          </a:p>
+        </p:txBody>
+      </p:sp>
+      <p:sp>
+        <p:nvSpPr>
+          <p:cNvPr id="20" name="Text 18"/>
+          <p:cNvSpPr/>
+          <p:nvPr/>
+        </p:nvSpPr>
+        <p:spPr>
+          <a:xfrm>
+            <a:off x="1115568" y="2642616"/>
+            <a:ext cx="3172968" cy="457200"/>
+          </a:xfrm>
+          <a:prstGeom prst="rect">
+            <a:avLst/>
+          </a:prstGeom>
+          <a:noFill/>
+          <a:ln/>
+        </p:spPr>
+        <p:txBody>
+          <a:bodyPr wrap="square" lIns="0" tIns="0" rIns="0" bIns="0" rtlCol="0" anchor="t"/>
+          <a:lstStyle/>
+          <a:p>
+            <a:pPr marL="0" marR="0" lvl="0" indent="0" algn="l" defTabSz="914400" rtl="0" eaLnBrk="1" fontAlgn="auto" latinLnBrk="0" hangingPunct="1">
+              <a:lnSpc>
+                <a:spcPct val="108000"/>
+              </a:lnSpc>
+              <a:spcBef>
+                <a:spcPts val="0"/>
+              </a:spcBef>
+              <a:spcAft>
+                <a:spcPts val="0"/>
+              </a:spcAft>
+              <a:buClrTx/>
+              <a:buSzTx/>
+              <a:buFontTx/>
+              <a:buNone/>
+              <a:tabLst/>
+              <a:defRPr/>
+            </a:pPr>
+            <a:r>
+              <a:rPr kumimoji="0" lang="en-US" sz="870" b="0" i="0" u="none" strike="noStrike" kern="1200" cap="none" spc="0" normalizeH="0" baseline="0" noProof="0" dirty="0">
+                <a:ln>
+                  <a:noFill/>
+                </a:ln>
+                <a:solidFill>
+                  <a:srgbClr val="AAB4C4"/>
+                </a:solidFill>
+                <a:effectLst/>
+                <a:uLnTx/>
+                <a:uFillTx/>
+                <a:latin typeface="Calibri" pitchFamily="34" charset="0"/>
+                <a:ea typeface="Calibri" pitchFamily="34" charset="-122"/>
+                <a:cs typeface="Calibri" pitchFamily="34" charset="-120"/>
+              </a:rPr>
+              <a:t>LangSmith traces every step by name (auth.login_attempt, document_processing, run_risk_analysis) — intent is visible, not just code.</a:t>
+            </a:r>
+            <a:endParaRPr kumimoji="0" lang="en-US" sz="870" b="0" i="0" u="none" strike="noStrike" kern="1200" cap="none" spc="0" normalizeH="0" baseline="0" noProof="0" dirty="0">
+              <a:ln>
+                <a:noFill/>
+              </a:ln>
+              <a:solidFill>
+                <a:prstClr val="black"/>
+              </a:solidFill>
+              <a:effectLst/>
+              <a:uLnTx/>
+              <a:uFillTx/>
+              <a:latin typeface="Calibri" panose="020F0502020204030204"/>
+              <a:ea typeface="+mn-ea"/>
+              <a:cs typeface="+mn-cs"/>
+            </a:endParaRPr>
+          </a:p>
+        </p:txBody>
+      </p:sp>
+      <p:sp>
+        <p:nvSpPr>
+          <p:cNvPr id="21" name="Shape 19"/>
+          <p:cNvSpPr/>
+          <p:nvPr/>
+        </p:nvSpPr>
+        <p:spPr>
+          <a:xfrm>
+            <a:off x="4709160" y="2331720"/>
+            <a:ext cx="3977640" cy="841248"/>
           </a:xfrm>
           <a:prstGeom prst="roundRect">
             <a:avLst>
-              <a:gd name="adj" fmla="val 12903"/>
+              <a:gd name="adj" fmla="val 6522"/>
             </a:avLst>
           </a:prstGeom>
           <a:solidFill>
             <a:srgbClr val="162032"/>
           </a:solidFill>
-          <a:ln/>
+          <a:ln w="9525">
+            <a:solidFill>
+              <a:srgbClr val="233047"/>
+            </a:solidFill>
+            <a:prstDash val="solid"/>
+          </a:ln>
           <a:effectLst>
-            <a:outerShdw blurRad="50800" dist="25400" dir="2700000" algn="bl" rotWithShape="0">
+            <a:outerShdw blurRad="76200" dist="25400" dir="5400000" algn="bl" rotWithShape="0">
               <a:srgbClr val="000000">
-                <a:alpha val="12000"/>
+                <a:alpha val="16000"/>
               </a:srgbClr>
             </a:outerShdw>
           </a:effectLst>
@@ -14276,14 +15027,36 @@
       </p:sp>
       <p:sp>
         <p:nvSpPr>
-          <p:cNvPr id="18" name="Text 16"/>
-          <p:cNvSpPr/>
-          <p:nvPr/>
-        </p:nvSpPr>
-        <p:spPr>
-          <a:xfrm>
-            <a:off x="4846320" y="3200400"/>
-            <a:ext cx="1097280" cy="384048"/>
+          <p:cNvPr id="22" name="Shape 20"/>
+          <p:cNvSpPr/>
+          <p:nvPr/>
+        </p:nvSpPr>
+        <p:spPr>
+          <a:xfrm>
+            <a:off x="4855464" y="2459736"/>
+            <a:ext cx="402336" cy="402336"/>
+          </a:xfrm>
+          <a:prstGeom prst="ellipse">
+            <a:avLst/>
+          </a:prstGeom>
+          <a:solidFill>
+            <a:srgbClr val="F5A623">
+              <a:alpha val="20000"/>
+            </a:srgbClr>
+          </a:solidFill>
+          <a:ln/>
+        </p:spPr>
+      </p:sp>
+      <p:sp>
+        <p:nvSpPr>
+          <p:cNvPr id="23" name="Text 21"/>
+          <p:cNvSpPr/>
+          <p:nvPr/>
+        </p:nvSpPr>
+        <p:spPr>
+          <a:xfrm>
+            <a:off x="4855464" y="2459736"/>
+            <a:ext cx="402336" cy="402336"/>
           </a:xfrm>
           <a:prstGeom prst="rect">
             <a:avLst/>
@@ -14295,31 +15068,67 @@
           <a:bodyPr wrap="square" lIns="0" tIns="0" rIns="0" bIns="0" rtlCol="0" anchor="ctr"/>
           <a:lstStyle/>
           <a:p>
-            <a:pPr marL="0" indent="0">
-              <a:buNone/>
-            </a:pPr>
-            <a:r>
-              <a:rPr lang="en-US" sz="1000" b="1" dirty="0">
-                <a:solidFill>
-                  <a:srgbClr val="059669"/>
-                </a:solidFill>
-              </a:rPr>
-              <a:t>🏷️ Version  </a:t>
-            </a:r>
-            <a:endParaRPr lang="en-US" sz="1000" dirty="0"/>
-          </a:p>
-        </p:txBody>
-      </p:sp>
-      <p:sp>
-        <p:nvSpPr>
-          <p:cNvPr id="19" name="Text 17"/>
-          <p:cNvSpPr/>
-          <p:nvPr/>
-        </p:nvSpPr>
-        <p:spPr>
-          <a:xfrm>
-            <a:off x="5760720" y="3200400"/>
-            <a:ext cx="2286000" cy="384048"/>
+            <a:pPr marL="0" marR="0" lvl="0" indent="0" algn="ctr" defTabSz="914400" rtl="0" eaLnBrk="1" fontAlgn="auto" latinLnBrk="0" hangingPunct="1">
+              <a:lnSpc>
+                <a:spcPct val="100000"/>
+              </a:lnSpc>
+              <a:spcBef>
+                <a:spcPts val="0"/>
+              </a:spcBef>
+              <a:spcAft>
+                <a:spcPts val="0"/>
+              </a:spcAft>
+              <a:buClrTx/>
+              <a:buSzTx/>
+              <a:buFontTx/>
+              <a:buNone/>
+              <a:tabLst/>
+              <a:defRPr/>
+            </a:pPr>
+            <a:r>
+              <a:rPr kumimoji="0" lang="en-US" sz="1400" b="0" i="0" u="none" strike="noStrike" kern="1200" cap="none" spc="0" normalizeH="0" baseline="0" noProof="0" dirty="0">
+                <a:ln>
+                  <a:noFill/>
+                </a:ln>
+                <a:solidFill>
+                  <a:srgbClr val="F5A623"/>
+                </a:solidFill>
+                <a:effectLst/>
+                <a:uLnTx/>
+                <a:uFillTx/>
+                <a:latin typeface="Calibri" panose="020F0502020204030204"/>
+                <a:ea typeface="+mn-ea"/>
+                <a:cs typeface="+mn-cs"/>
+              </a:rPr>
+              <a:t>🛡</a:t>
+            </a:r>
+            <a:endParaRPr kumimoji="0" lang="en-US" sz="1400" b="0" i="0" u="none" strike="noStrike" kern="1200" cap="none" spc="0" normalizeH="0" baseline="0" noProof="0" dirty="0">
+              <a:ln>
+                <a:noFill/>
+              </a:ln>
+              <a:solidFill>
+                <a:prstClr val="black"/>
+              </a:solidFill>
+              <a:effectLst/>
+              <a:uLnTx/>
+              <a:uFillTx/>
+              <a:latin typeface="Calibri" panose="020F0502020204030204"/>
+              <a:ea typeface="+mn-ea"/>
+              <a:cs typeface="+mn-cs"/>
+            </a:endParaRPr>
+          </a:p>
+        </p:txBody>
+      </p:sp>
+      <p:sp>
+        <p:nvSpPr>
+          <p:cNvPr id="24" name="Text 22"/>
+          <p:cNvSpPr/>
+          <p:nvPr/>
+        </p:nvSpPr>
+        <p:spPr>
+          <a:xfrm>
+            <a:off x="5367528" y="2423160"/>
+            <a:ext cx="3172968" cy="219456"/>
           </a:xfrm>
           <a:prstGeom prst="rect">
             <a:avLst/>
@@ -14331,34 +15140,195 @@
           <a:bodyPr wrap="square" lIns="0" tIns="0" rIns="0" bIns="0" rtlCol="0" anchor="ctr"/>
           <a:lstStyle/>
           <a:p>
-            <a:pPr marL="0" indent="0">
-              <a:buNone/>
-            </a:pPr>
-            <a:r>
-              <a:rPr lang="en-US" sz="950" dirty="0">
+            <a:pPr marL="0" marR="0" lvl="0" indent="0" algn="l" defTabSz="914400" rtl="0" eaLnBrk="1" fontAlgn="auto" latinLnBrk="0" hangingPunct="1">
+              <a:lnSpc>
+                <a:spcPct val="100000"/>
+              </a:lnSpc>
+              <a:spcBef>
+                <a:spcPts val="0"/>
+              </a:spcBef>
+              <a:spcAft>
+                <a:spcPts val="0"/>
+              </a:spcAft>
+              <a:buClrTx/>
+              <a:buSzTx/>
+              <a:buFontTx/>
+              <a:buNone/>
+              <a:tabLst/>
+              <a:defRPr/>
+            </a:pPr>
+            <a:r>
+              <a:rPr kumimoji="0" lang="en-US" sz="1200" b="1" i="0" u="none" strike="noStrike" kern="1200" cap="none" spc="0" normalizeH="0" baseline="0" noProof="0" dirty="0">
+                <a:ln>
+                  <a:noFill/>
+                </a:ln>
                 <a:solidFill>
                   <a:srgbClr val="FFFFFF"/>
                 </a:solidFill>
-                <a:latin typeface="Courier New" pitchFamily="34" charset="0"/>
-                <a:ea typeface="Courier New" pitchFamily="34" charset="-122"/>
-                <a:cs typeface="Courier New" pitchFamily="34" charset="-120"/>
-              </a:rPr>
-              <a:t>git tag v1.0 — main branch</a:t>
-            </a:r>
-            <a:endParaRPr lang="en-US" sz="950" dirty="0"/>
-          </a:p>
-        </p:txBody>
-      </p:sp>
-      <p:sp>
-        <p:nvSpPr>
-          <p:cNvPr id="20" name="Text 18"/>
-          <p:cNvSpPr/>
-          <p:nvPr/>
-        </p:nvSpPr>
-        <p:spPr>
-          <a:xfrm>
-            <a:off x="457200" y="4378495"/>
-            <a:ext cx="8229600" cy="475874"/>
+                <a:effectLst/>
+                <a:uLnTx/>
+                <a:uFillTx/>
+                <a:latin typeface="Cambria" pitchFamily="34" charset="0"/>
+                <a:ea typeface="Cambria" pitchFamily="34" charset="-122"/>
+                <a:cs typeface="Cambria" pitchFamily="34" charset="-120"/>
+              </a:rPr>
+              <a:t>Security &amp; Compliance</a:t>
+            </a:r>
+            <a:endParaRPr kumimoji="0" lang="en-US" sz="1200" b="0" i="0" u="none" strike="noStrike" kern="1200" cap="none" spc="0" normalizeH="0" baseline="0" noProof="0" dirty="0">
+              <a:ln>
+                <a:noFill/>
+              </a:ln>
+              <a:solidFill>
+                <a:prstClr val="black"/>
+              </a:solidFill>
+              <a:effectLst/>
+              <a:uLnTx/>
+              <a:uFillTx/>
+              <a:latin typeface="Calibri" panose="020F0502020204030204"/>
+              <a:ea typeface="+mn-ea"/>
+              <a:cs typeface="+mn-cs"/>
+            </a:endParaRPr>
+          </a:p>
+        </p:txBody>
+      </p:sp>
+      <p:sp>
+        <p:nvSpPr>
+          <p:cNvPr id="25" name="Text 23"/>
+          <p:cNvSpPr/>
+          <p:nvPr/>
+        </p:nvSpPr>
+        <p:spPr>
+          <a:xfrm>
+            <a:off x="5367528" y="2642616"/>
+            <a:ext cx="3172968" cy="457200"/>
+          </a:xfrm>
+          <a:prstGeom prst="rect">
+            <a:avLst/>
+          </a:prstGeom>
+          <a:noFill/>
+          <a:ln/>
+        </p:spPr>
+        <p:txBody>
+          <a:bodyPr wrap="square" lIns="0" tIns="0" rIns="0" bIns="0" rtlCol="0" anchor="t"/>
+          <a:lstStyle/>
+          <a:p>
+            <a:pPr marL="0" marR="0" lvl="0" indent="0" algn="l" defTabSz="914400" rtl="0" eaLnBrk="1" fontAlgn="auto" latinLnBrk="0" hangingPunct="1">
+              <a:lnSpc>
+                <a:spcPct val="108000"/>
+              </a:lnSpc>
+              <a:spcBef>
+                <a:spcPts val="0"/>
+              </a:spcBef>
+              <a:spcAft>
+                <a:spcPts val="0"/>
+              </a:spcAft>
+              <a:buClrTx/>
+              <a:buSzTx/>
+              <a:buFontTx/>
+              <a:buNone/>
+              <a:tabLst/>
+              <a:defRPr/>
+            </a:pPr>
+            <a:r>
+              <a:rPr kumimoji="0" lang="en-US" sz="870" b="0" i="0" u="none" strike="noStrike" kern="1200" cap="none" spc="0" normalizeH="0" baseline="0" noProof="0" dirty="0">
+                <a:ln>
+                  <a:noFill/>
+                </a:ln>
+                <a:solidFill>
+                  <a:srgbClr val="AAB4C4"/>
+                </a:solidFill>
+                <a:effectLst/>
+                <a:uLnTx/>
+                <a:uFillTx/>
+                <a:latin typeface="Calibri" pitchFamily="34" charset="0"/>
+                <a:ea typeface="Calibri" pitchFamily="34" charset="-122"/>
+                <a:cs typeface="Calibri" pitchFamily="34" charset="-120"/>
+              </a:rPr>
+              <a:t>JWT + bcrypt authentication; 13 secure environment settings kept out of the Docker image, never baked into the build.</a:t>
+            </a:r>
+            <a:endParaRPr kumimoji="0" lang="en-US" sz="870" b="0" i="0" u="none" strike="noStrike" kern="1200" cap="none" spc="0" normalizeH="0" baseline="0" noProof="0" dirty="0">
+              <a:ln>
+                <a:noFill/>
+              </a:ln>
+              <a:solidFill>
+                <a:prstClr val="black"/>
+              </a:solidFill>
+              <a:effectLst/>
+              <a:uLnTx/>
+              <a:uFillTx/>
+              <a:latin typeface="Calibri" panose="020F0502020204030204"/>
+              <a:ea typeface="+mn-ea"/>
+              <a:cs typeface="+mn-cs"/>
+            </a:endParaRPr>
+          </a:p>
+        </p:txBody>
+      </p:sp>
+      <p:sp>
+        <p:nvSpPr>
+          <p:cNvPr id="26" name="Shape 24"/>
+          <p:cNvSpPr/>
+          <p:nvPr/>
+        </p:nvSpPr>
+        <p:spPr>
+          <a:xfrm>
+            <a:off x="457200" y="3246120"/>
+            <a:ext cx="3977640" cy="841248"/>
+          </a:xfrm>
+          <a:prstGeom prst="roundRect">
+            <a:avLst>
+              <a:gd name="adj" fmla="val 6522"/>
+            </a:avLst>
+          </a:prstGeom>
+          <a:solidFill>
+            <a:srgbClr val="162032"/>
+          </a:solidFill>
+          <a:ln w="9525">
+            <a:solidFill>
+              <a:srgbClr val="233047"/>
+            </a:solidFill>
+            <a:prstDash val="solid"/>
+          </a:ln>
+          <a:effectLst>
+            <a:outerShdw blurRad="76200" dist="25400" dir="5400000" algn="bl" rotWithShape="0">
+              <a:srgbClr val="000000">
+                <a:alpha val="16000"/>
+              </a:srgbClr>
+            </a:outerShdw>
+          </a:effectLst>
+        </p:spPr>
+      </p:sp>
+      <p:sp>
+        <p:nvSpPr>
+          <p:cNvPr id="27" name="Shape 25"/>
+          <p:cNvSpPr/>
+          <p:nvPr/>
+        </p:nvSpPr>
+        <p:spPr>
+          <a:xfrm>
+            <a:off x="603504" y="3374136"/>
+            <a:ext cx="402336" cy="402336"/>
+          </a:xfrm>
+          <a:prstGeom prst="ellipse">
+            <a:avLst/>
+          </a:prstGeom>
+          <a:solidFill>
+            <a:srgbClr val="E8544E">
+              <a:alpha val="20000"/>
+            </a:srgbClr>
+          </a:solidFill>
+          <a:ln/>
+        </p:spPr>
+      </p:sp>
+      <p:sp>
+        <p:nvSpPr>
+          <p:cNvPr id="28" name="Text 26"/>
+          <p:cNvSpPr/>
+          <p:nvPr/>
+        </p:nvSpPr>
+        <p:spPr>
+          <a:xfrm>
+            <a:off x="603504" y="3374136"/>
+            <a:ext cx="402336" cy="402336"/>
           </a:xfrm>
           <a:prstGeom prst="rect">
             <a:avLst/>
@@ -14370,22 +15340,479 @@
           <a:bodyPr wrap="square" lIns="0" tIns="0" rIns="0" bIns="0" rtlCol="0" anchor="ctr"/>
           <a:lstStyle/>
           <a:p>
-            <a:pPr marL="0" indent="0" algn="ctr">
-              <a:buNone/>
-            </a:pPr>
-            <a:r>
-              <a:rPr lang="en-US" sz="1100" dirty="0">
-                <a:solidFill>
-                  <a:srgbClr val="94A3B8"/>
-                </a:solidFill>
-              </a:rPr>
-              <a:t>Akash Chaurasiya  ·  Ashu Sharma  ·  EY Training 2026  </a:t>
-            </a:r>
-            <a:endParaRPr lang="en-US" sz="1100" dirty="0"/>
+            <a:pPr marL="0" marR="0" lvl="0" indent="0" algn="ctr" defTabSz="914400" rtl="0" eaLnBrk="1" fontAlgn="auto" latinLnBrk="0" hangingPunct="1">
+              <a:lnSpc>
+                <a:spcPct val="100000"/>
+              </a:lnSpc>
+              <a:spcBef>
+                <a:spcPts val="0"/>
+              </a:spcBef>
+              <a:spcAft>
+                <a:spcPts val="0"/>
+              </a:spcAft>
+              <a:buClrTx/>
+              <a:buSzTx/>
+              <a:buFontTx/>
+              <a:buNone/>
+              <a:tabLst/>
+              <a:defRPr/>
+            </a:pPr>
+            <a:r>
+              <a:rPr kumimoji="0" lang="en-US" sz="1400" b="0" i="0" u="none" strike="noStrike" kern="1200" cap="none" spc="0" normalizeH="0" baseline="0" noProof="0" dirty="0">
+                <a:ln>
+                  <a:noFill/>
+                </a:ln>
+                <a:solidFill>
+                  <a:srgbClr val="E8544E"/>
+                </a:solidFill>
+                <a:effectLst/>
+                <a:uLnTx/>
+                <a:uFillTx/>
+                <a:latin typeface="Calibri" panose="020F0502020204030204"/>
+                <a:ea typeface="+mn-ea"/>
+                <a:cs typeface="+mn-cs"/>
+              </a:rPr>
+              <a:t>✔</a:t>
+            </a:r>
+            <a:endParaRPr kumimoji="0" lang="en-US" sz="1400" b="0" i="0" u="none" strike="noStrike" kern="1200" cap="none" spc="0" normalizeH="0" baseline="0" noProof="0" dirty="0">
+              <a:ln>
+                <a:noFill/>
+              </a:ln>
+              <a:solidFill>
+                <a:prstClr val="black"/>
+              </a:solidFill>
+              <a:effectLst/>
+              <a:uLnTx/>
+              <a:uFillTx/>
+              <a:latin typeface="Calibri" panose="020F0502020204030204"/>
+              <a:ea typeface="+mn-ea"/>
+              <a:cs typeface="+mn-cs"/>
+            </a:endParaRPr>
+          </a:p>
+        </p:txBody>
+      </p:sp>
+      <p:sp>
+        <p:nvSpPr>
+          <p:cNvPr id="29" name="Text 27"/>
+          <p:cNvSpPr/>
+          <p:nvPr/>
+        </p:nvSpPr>
+        <p:spPr>
+          <a:xfrm>
+            <a:off x="1115568" y="3337560"/>
+            <a:ext cx="3172968" cy="219456"/>
+          </a:xfrm>
+          <a:prstGeom prst="rect">
+            <a:avLst/>
+          </a:prstGeom>
+          <a:noFill/>
+          <a:ln/>
+        </p:spPr>
+        <p:txBody>
+          <a:bodyPr wrap="square" lIns="0" tIns="0" rIns="0" bIns="0" rtlCol="0" anchor="ctr"/>
+          <a:lstStyle/>
+          <a:p>
+            <a:pPr marL="0" marR="0" lvl="0" indent="0" algn="l" defTabSz="914400" rtl="0" eaLnBrk="1" fontAlgn="auto" latinLnBrk="0" hangingPunct="1">
+              <a:lnSpc>
+                <a:spcPct val="100000"/>
+              </a:lnSpc>
+              <a:spcBef>
+                <a:spcPts val="0"/>
+              </a:spcBef>
+              <a:spcAft>
+                <a:spcPts val="0"/>
+              </a:spcAft>
+              <a:buClrTx/>
+              <a:buSzTx/>
+              <a:buFontTx/>
+              <a:buNone/>
+              <a:tabLst/>
+              <a:defRPr/>
+            </a:pPr>
+            <a:r>
+              <a:rPr kumimoji="0" lang="en-US" sz="1200" b="1" i="0" u="none" strike="noStrike" kern="1200" cap="none" spc="0" normalizeH="0" baseline="0" noProof="0" dirty="0">
+                <a:ln>
+                  <a:noFill/>
+                </a:ln>
+                <a:solidFill>
+                  <a:srgbClr val="FFFFFF"/>
+                </a:solidFill>
+                <a:effectLst/>
+                <a:uLnTx/>
+                <a:uFillTx/>
+                <a:latin typeface="Cambria" pitchFamily="34" charset="0"/>
+                <a:ea typeface="Cambria" pitchFamily="34" charset="-122"/>
+                <a:cs typeface="Cambria" pitchFamily="34" charset="-120"/>
+              </a:rPr>
+              <a:t>Testing Standards</a:t>
+            </a:r>
+            <a:endParaRPr kumimoji="0" lang="en-US" sz="1200" b="0" i="0" u="none" strike="noStrike" kern="1200" cap="none" spc="0" normalizeH="0" baseline="0" noProof="0" dirty="0">
+              <a:ln>
+                <a:noFill/>
+              </a:ln>
+              <a:solidFill>
+                <a:prstClr val="black"/>
+              </a:solidFill>
+              <a:effectLst/>
+              <a:uLnTx/>
+              <a:uFillTx/>
+              <a:latin typeface="Calibri" panose="020F0502020204030204"/>
+              <a:ea typeface="+mn-ea"/>
+              <a:cs typeface="+mn-cs"/>
+            </a:endParaRPr>
+          </a:p>
+        </p:txBody>
+      </p:sp>
+      <p:sp>
+        <p:nvSpPr>
+          <p:cNvPr id="30" name="Text 28"/>
+          <p:cNvSpPr/>
+          <p:nvPr/>
+        </p:nvSpPr>
+        <p:spPr>
+          <a:xfrm>
+            <a:off x="1115568" y="3557016"/>
+            <a:ext cx="3172968" cy="457200"/>
+          </a:xfrm>
+          <a:prstGeom prst="rect">
+            <a:avLst/>
+          </a:prstGeom>
+          <a:noFill/>
+          <a:ln/>
+        </p:spPr>
+        <p:txBody>
+          <a:bodyPr wrap="square" lIns="0" tIns="0" rIns="0" bIns="0" rtlCol="0" anchor="t"/>
+          <a:lstStyle/>
+          <a:p>
+            <a:pPr marL="0" marR="0" lvl="0" indent="0" algn="l" defTabSz="914400" rtl="0" eaLnBrk="1" fontAlgn="auto" latinLnBrk="0" hangingPunct="1">
+              <a:lnSpc>
+                <a:spcPct val="108000"/>
+              </a:lnSpc>
+              <a:spcBef>
+                <a:spcPts val="0"/>
+              </a:spcBef>
+              <a:spcAft>
+                <a:spcPts val="0"/>
+              </a:spcAft>
+              <a:buClrTx/>
+              <a:buSzTx/>
+              <a:buFontTx/>
+              <a:buNone/>
+              <a:tabLst/>
+              <a:defRPr/>
+            </a:pPr>
+            <a:r>
+              <a:rPr kumimoji="0" lang="en-US" sz="870" b="0" i="0" u="none" strike="noStrike" kern="1200" cap="none" spc="0" normalizeH="0" baseline="0" noProof="0" dirty="0">
+                <a:ln>
+                  <a:noFill/>
+                </a:ln>
+                <a:solidFill>
+                  <a:srgbClr val="AAB4C4"/>
+                </a:solidFill>
+                <a:effectLst/>
+                <a:uLnTx/>
+                <a:uFillTx/>
+                <a:latin typeface="Calibri" pitchFamily="34" charset="0"/>
+                <a:ea typeface="Calibri" pitchFamily="34" charset="-122"/>
+                <a:cs typeface="Calibri" pitchFamily="34" charset="-120"/>
+              </a:rPr>
+              <a:t>96 unit tests across every module, plus DeepEval (0.22 hallucination score) and RAGAS (0.88 faithfulness) — all run in CI in 6 seconds.</a:t>
+            </a:r>
+            <a:endParaRPr kumimoji="0" lang="en-US" sz="870" b="0" i="0" u="none" strike="noStrike" kern="1200" cap="none" spc="0" normalizeH="0" baseline="0" noProof="0" dirty="0">
+              <a:ln>
+                <a:noFill/>
+              </a:ln>
+              <a:solidFill>
+                <a:prstClr val="black"/>
+              </a:solidFill>
+              <a:effectLst/>
+              <a:uLnTx/>
+              <a:uFillTx/>
+              <a:latin typeface="Calibri" panose="020F0502020204030204"/>
+              <a:ea typeface="+mn-ea"/>
+              <a:cs typeface="+mn-cs"/>
+            </a:endParaRPr>
+          </a:p>
+        </p:txBody>
+      </p:sp>
+      <p:sp>
+        <p:nvSpPr>
+          <p:cNvPr id="31" name="Shape 29"/>
+          <p:cNvSpPr/>
+          <p:nvPr/>
+        </p:nvSpPr>
+        <p:spPr>
+          <a:xfrm>
+            <a:off x="4709160" y="3246120"/>
+            <a:ext cx="3977640" cy="841248"/>
+          </a:xfrm>
+          <a:prstGeom prst="roundRect">
+            <a:avLst>
+              <a:gd name="adj" fmla="val 6522"/>
+            </a:avLst>
+          </a:prstGeom>
+          <a:solidFill>
+            <a:srgbClr val="162032"/>
+          </a:solidFill>
+          <a:ln w="9525">
+            <a:solidFill>
+              <a:srgbClr val="233047"/>
+            </a:solidFill>
+            <a:prstDash val="solid"/>
+          </a:ln>
+          <a:effectLst>
+            <a:outerShdw blurRad="76200" dist="25400" dir="5400000" algn="bl" rotWithShape="0">
+              <a:srgbClr val="000000">
+                <a:alpha val="16000"/>
+              </a:srgbClr>
+            </a:outerShdw>
+          </a:effectLst>
+        </p:spPr>
+      </p:sp>
+      <p:sp>
+        <p:nvSpPr>
+          <p:cNvPr id="32" name="Shape 30"/>
+          <p:cNvSpPr/>
+          <p:nvPr/>
+        </p:nvSpPr>
+        <p:spPr>
+          <a:xfrm>
+            <a:off x="4855464" y="3374136"/>
+            <a:ext cx="402336" cy="402336"/>
+          </a:xfrm>
+          <a:prstGeom prst="ellipse">
+            <a:avLst/>
+          </a:prstGeom>
+          <a:solidFill>
+            <a:srgbClr val="3B82F6">
+              <a:alpha val="20000"/>
+            </a:srgbClr>
+          </a:solidFill>
+          <a:ln/>
+        </p:spPr>
+      </p:sp>
+      <p:sp>
+        <p:nvSpPr>
+          <p:cNvPr id="33" name="Text 31"/>
+          <p:cNvSpPr/>
+          <p:nvPr/>
+        </p:nvSpPr>
+        <p:spPr>
+          <a:xfrm>
+            <a:off x="4855464" y="3374136"/>
+            <a:ext cx="402336" cy="402336"/>
+          </a:xfrm>
+          <a:prstGeom prst="rect">
+            <a:avLst/>
+          </a:prstGeom>
+          <a:noFill/>
+          <a:ln/>
+        </p:spPr>
+        <p:txBody>
+          <a:bodyPr wrap="square" lIns="0" tIns="0" rIns="0" bIns="0" rtlCol="0" anchor="ctr"/>
+          <a:lstStyle/>
+          <a:p>
+            <a:pPr marL="0" marR="0" lvl="0" indent="0" algn="ctr" defTabSz="914400" rtl="0" eaLnBrk="1" fontAlgn="auto" latinLnBrk="0" hangingPunct="1">
+              <a:lnSpc>
+                <a:spcPct val="100000"/>
+              </a:lnSpc>
+              <a:spcBef>
+                <a:spcPts val="0"/>
+              </a:spcBef>
+              <a:spcAft>
+                <a:spcPts val="0"/>
+              </a:spcAft>
+              <a:buClrTx/>
+              <a:buSzTx/>
+              <a:buFontTx/>
+              <a:buNone/>
+              <a:tabLst/>
+              <a:defRPr/>
+            </a:pPr>
+            <a:r>
+              <a:rPr kumimoji="0" lang="en-US" sz="1400" b="0" i="0" u="none" strike="noStrike" kern="1200" cap="none" spc="0" normalizeH="0" baseline="0" noProof="0" dirty="0">
+                <a:ln>
+                  <a:noFill/>
+                </a:ln>
+                <a:solidFill>
+                  <a:srgbClr val="3B82F6"/>
+                </a:solidFill>
+                <a:effectLst/>
+                <a:uLnTx/>
+                <a:uFillTx/>
+                <a:latin typeface="Calibri" panose="020F0502020204030204"/>
+                <a:ea typeface="+mn-ea"/>
+                <a:cs typeface="+mn-cs"/>
+              </a:rPr>
+              <a:t>📦</a:t>
+            </a:r>
+            <a:endParaRPr kumimoji="0" lang="en-US" sz="1400" b="0" i="0" u="none" strike="noStrike" kern="1200" cap="none" spc="0" normalizeH="0" baseline="0" noProof="0" dirty="0">
+              <a:ln>
+                <a:noFill/>
+              </a:ln>
+              <a:solidFill>
+                <a:prstClr val="black"/>
+              </a:solidFill>
+              <a:effectLst/>
+              <a:uLnTx/>
+              <a:uFillTx/>
+              <a:latin typeface="Calibri" panose="020F0502020204030204"/>
+              <a:ea typeface="+mn-ea"/>
+              <a:cs typeface="+mn-cs"/>
+            </a:endParaRPr>
+          </a:p>
+        </p:txBody>
+      </p:sp>
+      <p:sp>
+        <p:nvSpPr>
+          <p:cNvPr id="34" name="Text 32"/>
+          <p:cNvSpPr/>
+          <p:nvPr/>
+        </p:nvSpPr>
+        <p:spPr>
+          <a:xfrm>
+            <a:off x="5367528" y="3337560"/>
+            <a:ext cx="3172968" cy="219456"/>
+          </a:xfrm>
+          <a:prstGeom prst="rect">
+            <a:avLst/>
+          </a:prstGeom>
+          <a:noFill/>
+          <a:ln/>
+        </p:spPr>
+        <p:txBody>
+          <a:bodyPr wrap="square" lIns="0" tIns="0" rIns="0" bIns="0" rtlCol="0" anchor="ctr"/>
+          <a:lstStyle/>
+          <a:p>
+            <a:pPr marL="0" marR="0" lvl="0" indent="0" algn="l" defTabSz="914400" rtl="0" eaLnBrk="1" fontAlgn="auto" latinLnBrk="0" hangingPunct="1">
+              <a:lnSpc>
+                <a:spcPct val="100000"/>
+              </a:lnSpc>
+              <a:spcBef>
+                <a:spcPts val="0"/>
+              </a:spcBef>
+              <a:spcAft>
+                <a:spcPts val="0"/>
+              </a:spcAft>
+              <a:buClrTx/>
+              <a:buSzTx/>
+              <a:buFontTx/>
+              <a:buNone/>
+              <a:tabLst/>
+              <a:defRPr/>
+            </a:pPr>
+            <a:r>
+              <a:rPr kumimoji="0" lang="en-US" sz="1200" b="1" i="0" u="none" strike="noStrike" kern="1200" cap="none" spc="0" normalizeH="0" baseline="0" noProof="0" dirty="0">
+                <a:ln>
+                  <a:noFill/>
+                </a:ln>
+                <a:solidFill>
+                  <a:srgbClr val="FFFFFF"/>
+                </a:solidFill>
+                <a:effectLst/>
+                <a:uLnTx/>
+                <a:uFillTx/>
+                <a:latin typeface="Cambria" pitchFamily="34" charset="0"/>
+                <a:ea typeface="Cambria" pitchFamily="34" charset="-122"/>
+                <a:cs typeface="Cambria" pitchFamily="34" charset="-120"/>
+              </a:rPr>
+              <a:t>Version Control</a:t>
+            </a:r>
+            <a:endParaRPr kumimoji="0" lang="en-US" sz="1200" b="0" i="0" u="none" strike="noStrike" kern="1200" cap="none" spc="0" normalizeH="0" baseline="0" noProof="0" dirty="0">
+              <a:ln>
+                <a:noFill/>
+              </a:ln>
+              <a:solidFill>
+                <a:prstClr val="black"/>
+              </a:solidFill>
+              <a:effectLst/>
+              <a:uLnTx/>
+              <a:uFillTx/>
+              <a:latin typeface="Calibri" panose="020F0502020204030204"/>
+              <a:ea typeface="+mn-ea"/>
+              <a:cs typeface="+mn-cs"/>
+            </a:endParaRPr>
+          </a:p>
+        </p:txBody>
+      </p:sp>
+      <p:sp>
+        <p:nvSpPr>
+          <p:cNvPr id="35" name="Text 33"/>
+          <p:cNvSpPr/>
+          <p:nvPr/>
+        </p:nvSpPr>
+        <p:spPr>
+          <a:xfrm>
+            <a:off x="5367528" y="3557016"/>
+            <a:ext cx="3172968" cy="457200"/>
+          </a:xfrm>
+          <a:prstGeom prst="rect">
+            <a:avLst/>
+          </a:prstGeom>
+          <a:noFill/>
+          <a:ln/>
+        </p:spPr>
+        <p:txBody>
+          <a:bodyPr wrap="square" lIns="0" tIns="0" rIns="0" bIns="0" rtlCol="0" anchor="t"/>
+          <a:lstStyle/>
+          <a:p>
+            <a:pPr marL="0" marR="0" lvl="0" indent="0" algn="l" defTabSz="914400" rtl="0" eaLnBrk="1" fontAlgn="auto" latinLnBrk="0" hangingPunct="1">
+              <a:lnSpc>
+                <a:spcPct val="108000"/>
+              </a:lnSpc>
+              <a:spcBef>
+                <a:spcPts val="0"/>
+              </a:spcBef>
+              <a:spcAft>
+                <a:spcPts val="0"/>
+              </a:spcAft>
+              <a:buClrTx/>
+              <a:buSzTx/>
+              <a:buFontTx/>
+              <a:buNone/>
+              <a:tabLst/>
+              <a:defRPr/>
+            </a:pPr>
+            <a:r>
+              <a:rPr kumimoji="0" lang="en-US" sz="870" b="0" i="0" u="none" strike="noStrike" kern="1200" cap="none" spc="0" normalizeH="0" baseline="0" noProof="0" dirty="0">
+                <a:ln>
+                  <a:noFill/>
+                </a:ln>
+                <a:solidFill>
+                  <a:srgbClr val="AAB4C4"/>
+                </a:solidFill>
+                <a:effectLst/>
+                <a:uLnTx/>
+                <a:uFillTx/>
+                <a:latin typeface="Calibri" pitchFamily="34" charset="0"/>
+                <a:ea typeface="Calibri" pitchFamily="34" charset="-122"/>
+                <a:cs typeface="Calibri" pitchFamily="34" charset="-120"/>
+              </a:rPr>
+              <a:t>Trunk-based flow: git push → tests → Docker build → push to ACR → deploy — a clean, atomic, automated pipeline to Azure.</a:t>
+            </a:r>
+            <a:endParaRPr kumimoji="0" lang="en-US" sz="870" b="0" i="0" u="none" strike="noStrike" kern="1200" cap="none" spc="0" normalizeH="0" baseline="0" noProof="0" dirty="0">
+              <a:ln>
+                <a:noFill/>
+              </a:ln>
+              <a:solidFill>
+                <a:prstClr val="black"/>
+              </a:solidFill>
+              <a:effectLst/>
+              <a:uLnTx/>
+              <a:uFillTx/>
+              <a:latin typeface="Calibri" panose="020F0502020204030204"/>
+              <a:ea typeface="+mn-ea"/>
+              <a:cs typeface="+mn-cs"/>
+            </a:endParaRPr>
           </a:p>
         </p:txBody>
       </p:sp>
     </p:spTree>
+    <p:extLst>
+      <p:ext uri="{BB962C8B-B14F-4D97-AF65-F5344CB8AC3E}">
+        <p14:creationId xmlns:p14="http://schemas.microsoft.com/office/powerpoint/2010/main" val="3343381645"/>
+      </p:ext>
+    </p:extLst>
   </p:cSld>
   <p:clrMapOvr>
     <a:masterClrMapping/>
@@ -14798,6 +16225,634 @@
   <p:transition spd="slow">
     <p:fade/>
   </p:transition>
+</p:sld>
+</file>
+
+<file path=ppt/slides/slide20.xml><?xml version="1.0" encoding="utf-8"?>
+<p:sld xmlns:a="http://schemas.openxmlformats.org/drawingml/2006/main" xmlns:r="http://schemas.openxmlformats.org/officeDocument/2006/relationships" xmlns:p="http://schemas.openxmlformats.org/presentationml/2006/main">
+  <p:cSld name="Slide 16">
+    <p:bg>
+      <p:bgPr>
+        <a:solidFill>
+          <a:srgbClr val="0F1B2D"/>
+        </a:solidFill>
+        <a:effectLst/>
+      </p:bgPr>
+    </p:bg>
+    <p:spTree>
+      <p:nvGrpSpPr>
+        <p:cNvPr id="1" name=""/>
+        <p:cNvGrpSpPr/>
+        <p:nvPr/>
+      </p:nvGrpSpPr>
+      <p:grpSpPr>
+        <a:xfrm>
+          <a:off x="0" y="0"/>
+          <a:ext cx="0" cy="0"/>
+          <a:chOff x="0" y="0"/>
+          <a:chExt cx="0" cy="0"/>
+        </a:xfrm>
+      </p:grpSpPr>
+      <p:sp>
+        <p:nvSpPr>
+          <p:cNvPr id="2" name="Shape 0"/>
+          <p:cNvSpPr/>
+          <p:nvPr/>
+        </p:nvSpPr>
+        <p:spPr>
+          <a:xfrm>
+            <a:off x="6858000" y="-914400"/>
+            <a:ext cx="3657600" cy="3657600"/>
+          </a:xfrm>
+          <a:prstGeom prst="ellipse">
+            <a:avLst/>
+          </a:prstGeom>
+          <a:solidFill>
+            <a:srgbClr val="2563EB">
+              <a:alpha val="12000"/>
+            </a:srgbClr>
+          </a:solidFill>
+          <a:ln/>
+        </p:spPr>
+      </p:sp>
+      <p:sp>
+        <p:nvSpPr>
+          <p:cNvPr id="3" name="Shape 1"/>
+          <p:cNvSpPr/>
+          <p:nvPr/>
+        </p:nvSpPr>
+        <p:spPr>
+          <a:xfrm>
+            <a:off x="-699967" y="2616086"/>
+            <a:ext cx="3200400" cy="3200400"/>
+          </a:xfrm>
+          <a:prstGeom prst="ellipse">
+            <a:avLst/>
+          </a:prstGeom>
+          <a:solidFill>
+            <a:srgbClr val="0891B2">
+              <a:alpha val="12000"/>
+            </a:srgbClr>
+          </a:solidFill>
+          <a:ln/>
+        </p:spPr>
+      </p:sp>
+      <p:sp>
+        <p:nvSpPr>
+          <p:cNvPr id="4" name="Shape 2"/>
+          <p:cNvSpPr/>
+          <p:nvPr/>
+        </p:nvSpPr>
+        <p:spPr>
+          <a:xfrm>
+            <a:off x="3474720" y="365760"/>
+            <a:ext cx="1280160" cy="256032"/>
+          </a:xfrm>
+          <a:prstGeom prst="roundRect">
+            <a:avLst>
+              <a:gd name="adj" fmla="val 50000"/>
+            </a:avLst>
+          </a:prstGeom>
+          <a:solidFill>
+            <a:srgbClr val="059669">
+              <a:alpha val="25000"/>
+            </a:srgbClr>
+          </a:solidFill>
+          <a:ln/>
+        </p:spPr>
+      </p:sp>
+      <p:sp>
+        <p:nvSpPr>
+          <p:cNvPr id="5" name="Text 3"/>
+          <p:cNvSpPr/>
+          <p:nvPr/>
+        </p:nvSpPr>
+        <p:spPr>
+          <a:xfrm>
+            <a:off x="3474720" y="365760"/>
+            <a:ext cx="1280160" cy="256032"/>
+          </a:xfrm>
+          <a:prstGeom prst="rect">
+            <a:avLst/>
+          </a:prstGeom>
+          <a:noFill/>
+          <a:ln/>
+        </p:spPr>
+        <p:txBody>
+          <a:bodyPr wrap="square" lIns="0" tIns="0" rIns="0" bIns="0" rtlCol="0" anchor="ctr"/>
+          <a:lstStyle/>
+          <a:p>
+            <a:pPr marL="0" indent="0" algn="ctr">
+              <a:buNone/>
+            </a:pPr>
+            <a:r>
+              <a:rPr lang="en-US" sz="900" b="1" kern="0" spc="150" dirty="0">
+                <a:solidFill>
+                  <a:srgbClr val="059669"/>
+                </a:solidFill>
+              </a:rPr>
+              <a:t>SUBMITTED</a:t>
+            </a:r>
+            <a:endParaRPr lang="en-US" sz="900" dirty="0"/>
+          </a:p>
+        </p:txBody>
+      </p:sp>
+      <p:sp>
+        <p:nvSpPr>
+          <p:cNvPr id="6" name="Text 4"/>
+          <p:cNvSpPr/>
+          <p:nvPr/>
+        </p:nvSpPr>
+        <p:spPr>
+          <a:xfrm>
+            <a:off x="91440" y="1275588"/>
+            <a:ext cx="8229600" cy="731520"/>
+          </a:xfrm>
+          <a:prstGeom prst="rect">
+            <a:avLst/>
+          </a:prstGeom>
+          <a:noFill/>
+          <a:ln/>
+        </p:spPr>
+        <p:txBody>
+          <a:bodyPr wrap="square" lIns="0" tIns="0" rIns="0" bIns="0" rtlCol="0" anchor="ctr"/>
+          <a:lstStyle/>
+          <a:p>
+            <a:pPr marL="0" indent="0" algn="ctr">
+              <a:buNone/>
+            </a:pPr>
+            <a:r>
+              <a:rPr lang="en-US" sz="4800" b="1" dirty="0">
+                <a:solidFill>
+                  <a:srgbClr val="FFFFFF"/>
+                </a:solidFill>
+                <a:latin typeface="Cambria" pitchFamily="34" charset="0"/>
+                <a:ea typeface="Cambria" pitchFamily="34" charset="-122"/>
+                <a:cs typeface="Cambria" pitchFamily="34" charset="-120"/>
+              </a:rPr>
+              <a:t>Thank You</a:t>
+            </a:r>
+            <a:endParaRPr lang="en-US" sz="4800" dirty="0"/>
+          </a:p>
+        </p:txBody>
+      </p:sp>
+      <p:sp>
+        <p:nvSpPr>
+          <p:cNvPr id="8" name="Shape 6"/>
+          <p:cNvSpPr/>
+          <p:nvPr/>
+        </p:nvSpPr>
+        <p:spPr>
+          <a:xfrm>
+            <a:off x="822960" y="2423160"/>
+            <a:ext cx="3520440" cy="566928"/>
+          </a:xfrm>
+          <a:prstGeom prst="roundRect">
+            <a:avLst>
+              <a:gd name="adj" fmla="val 12903"/>
+            </a:avLst>
+          </a:prstGeom>
+          <a:solidFill>
+            <a:srgbClr val="162032"/>
+          </a:solidFill>
+          <a:ln/>
+          <a:effectLst>
+            <a:outerShdw blurRad="50800" dist="25400" dir="2700000" algn="bl" rotWithShape="0">
+              <a:srgbClr val="000000">
+                <a:alpha val="12000"/>
+              </a:srgbClr>
+            </a:outerShdw>
+          </a:effectLst>
+        </p:spPr>
+      </p:sp>
+      <p:sp>
+        <p:nvSpPr>
+          <p:cNvPr id="9" name="Text 7"/>
+          <p:cNvSpPr/>
+          <p:nvPr/>
+        </p:nvSpPr>
+        <p:spPr>
+          <a:xfrm>
+            <a:off x="1005840" y="2487168"/>
+            <a:ext cx="1097280" cy="384048"/>
+          </a:xfrm>
+          <a:prstGeom prst="rect">
+            <a:avLst/>
+          </a:prstGeom>
+          <a:noFill/>
+          <a:ln/>
+        </p:spPr>
+        <p:txBody>
+          <a:bodyPr wrap="square" lIns="0" tIns="0" rIns="0" bIns="0" rtlCol="0" anchor="ctr"/>
+          <a:lstStyle/>
+          <a:p>
+            <a:pPr marL="0" indent="0">
+              <a:buNone/>
+            </a:pPr>
+            <a:r>
+              <a:rPr lang="en-US" sz="1000" b="1" dirty="0">
+                <a:solidFill>
+                  <a:srgbClr val="0891B2"/>
+                </a:solidFill>
+              </a:rPr>
+              <a:t>🌐 Live App  </a:t>
+            </a:r>
+            <a:endParaRPr lang="en-US" sz="1000" dirty="0"/>
+          </a:p>
+        </p:txBody>
+      </p:sp>
+      <p:sp>
+        <p:nvSpPr>
+          <p:cNvPr id="10" name="Text 8"/>
+          <p:cNvSpPr/>
+          <p:nvPr/>
+        </p:nvSpPr>
+        <p:spPr>
+          <a:xfrm>
+            <a:off x="1920240" y="2487168"/>
+            <a:ext cx="2286000" cy="384048"/>
+          </a:xfrm>
+          <a:prstGeom prst="rect">
+            <a:avLst/>
+          </a:prstGeom>
+          <a:noFill/>
+          <a:ln/>
+        </p:spPr>
+        <p:txBody>
+          <a:bodyPr wrap="square" lIns="0" tIns="0" rIns="0" bIns="0" rtlCol="0" anchor="ctr"/>
+          <a:lstStyle/>
+          <a:p>
+            <a:pPr marL="0" indent="0">
+              <a:buNone/>
+            </a:pPr>
+            <a:r>
+              <a:rPr lang="en-US" sz="950" dirty="0">
+                <a:solidFill>
+                  <a:srgbClr val="FFFFFF"/>
+                </a:solidFill>
+                <a:latin typeface="Courier New" pitchFamily="34" charset="0"/>
+                <a:ea typeface="Courier New" pitchFamily="34" charset="-122"/>
+                <a:cs typeface="Courier New" pitchFamily="34" charset="-120"/>
+              </a:rPr>
+              <a:t>creditriskplatform.azurewebsites.net</a:t>
+            </a:r>
+            <a:endParaRPr lang="en-US" sz="950" dirty="0"/>
+          </a:p>
+        </p:txBody>
+      </p:sp>
+      <p:sp>
+        <p:nvSpPr>
+          <p:cNvPr id="11" name="Shape 9"/>
+          <p:cNvSpPr/>
+          <p:nvPr/>
+        </p:nvSpPr>
+        <p:spPr>
+          <a:xfrm>
+            <a:off x="4663440" y="2423160"/>
+            <a:ext cx="3520440" cy="566928"/>
+          </a:xfrm>
+          <a:prstGeom prst="roundRect">
+            <a:avLst>
+              <a:gd name="adj" fmla="val 12903"/>
+            </a:avLst>
+          </a:prstGeom>
+          <a:solidFill>
+            <a:srgbClr val="162032"/>
+          </a:solidFill>
+          <a:ln/>
+          <a:effectLst>
+            <a:outerShdw blurRad="50800" dist="25400" dir="2700000" algn="bl" rotWithShape="0">
+              <a:srgbClr val="000000">
+                <a:alpha val="12000"/>
+              </a:srgbClr>
+            </a:outerShdw>
+          </a:effectLst>
+        </p:spPr>
+      </p:sp>
+      <p:sp>
+        <p:nvSpPr>
+          <p:cNvPr id="12" name="Text 10"/>
+          <p:cNvSpPr/>
+          <p:nvPr/>
+        </p:nvSpPr>
+        <p:spPr>
+          <a:xfrm>
+            <a:off x="4846320" y="2487168"/>
+            <a:ext cx="1097280" cy="384048"/>
+          </a:xfrm>
+          <a:prstGeom prst="rect">
+            <a:avLst/>
+          </a:prstGeom>
+          <a:noFill/>
+          <a:ln/>
+        </p:spPr>
+        <p:txBody>
+          <a:bodyPr wrap="square" lIns="0" tIns="0" rIns="0" bIns="0" rtlCol="0" anchor="ctr"/>
+          <a:lstStyle/>
+          <a:p>
+            <a:pPr marL="0" indent="0">
+              <a:buNone/>
+            </a:pPr>
+            <a:r>
+              <a:rPr lang="en-US" sz="1000" b="1" dirty="0">
+                <a:solidFill>
+                  <a:srgbClr val="2563EB"/>
+                </a:solidFill>
+              </a:rPr>
+              <a:t>💻 GitHub  </a:t>
+            </a:r>
+            <a:endParaRPr lang="en-US" sz="1000" dirty="0"/>
+          </a:p>
+        </p:txBody>
+      </p:sp>
+      <p:sp>
+        <p:nvSpPr>
+          <p:cNvPr id="13" name="Text 11"/>
+          <p:cNvSpPr/>
+          <p:nvPr/>
+        </p:nvSpPr>
+        <p:spPr>
+          <a:xfrm>
+            <a:off x="5760720" y="2487168"/>
+            <a:ext cx="2286000" cy="384048"/>
+          </a:xfrm>
+          <a:prstGeom prst="rect">
+            <a:avLst/>
+          </a:prstGeom>
+          <a:noFill/>
+          <a:ln/>
+        </p:spPr>
+        <p:txBody>
+          <a:bodyPr wrap="square" lIns="0" tIns="0" rIns="0" bIns="0" rtlCol="0" anchor="ctr"/>
+          <a:lstStyle/>
+          <a:p>
+            <a:pPr marL="0" indent="0">
+              <a:buNone/>
+            </a:pPr>
+            <a:r>
+              <a:rPr lang="en-US" sz="950" dirty="0">
+                <a:solidFill>
+                  <a:srgbClr val="FFFFFF"/>
+                </a:solidFill>
+                <a:latin typeface="Courier New" pitchFamily="34" charset="0"/>
+                <a:ea typeface="Courier New" pitchFamily="34" charset="-122"/>
+                <a:cs typeface="Courier New" pitchFamily="34" charset="-120"/>
+              </a:rPr>
+              <a:t>github.com/Chaurasiyakash0136/EY-Training-2026</a:t>
+            </a:r>
+            <a:endParaRPr lang="en-US" sz="950" dirty="0"/>
+          </a:p>
+        </p:txBody>
+      </p:sp>
+      <p:sp>
+        <p:nvSpPr>
+          <p:cNvPr id="14" name="Shape 12"/>
+          <p:cNvSpPr/>
+          <p:nvPr/>
+        </p:nvSpPr>
+        <p:spPr>
+          <a:xfrm>
+            <a:off x="822960" y="3136392"/>
+            <a:ext cx="3520440" cy="566928"/>
+          </a:xfrm>
+          <a:prstGeom prst="roundRect">
+            <a:avLst>
+              <a:gd name="adj" fmla="val 12903"/>
+            </a:avLst>
+          </a:prstGeom>
+          <a:solidFill>
+            <a:srgbClr val="162032"/>
+          </a:solidFill>
+          <a:ln/>
+          <a:effectLst>
+            <a:outerShdw blurRad="50800" dist="25400" dir="2700000" algn="bl" rotWithShape="0">
+              <a:srgbClr val="000000">
+                <a:alpha val="12000"/>
+              </a:srgbClr>
+            </a:outerShdw>
+          </a:effectLst>
+        </p:spPr>
+      </p:sp>
+      <p:sp>
+        <p:nvSpPr>
+          <p:cNvPr id="15" name="Text 13"/>
+          <p:cNvSpPr/>
+          <p:nvPr/>
+        </p:nvSpPr>
+        <p:spPr>
+          <a:xfrm>
+            <a:off x="1005840" y="3200400"/>
+            <a:ext cx="1097280" cy="384048"/>
+          </a:xfrm>
+          <a:prstGeom prst="rect">
+            <a:avLst/>
+          </a:prstGeom>
+          <a:noFill/>
+          <a:ln/>
+        </p:spPr>
+        <p:txBody>
+          <a:bodyPr wrap="square" lIns="0" tIns="0" rIns="0" bIns="0" rtlCol="0" anchor="ctr"/>
+          <a:lstStyle/>
+          <a:p>
+            <a:pPr marL="0" indent="0">
+              <a:buNone/>
+            </a:pPr>
+            <a:r>
+              <a:rPr lang="en-US" sz="1000" b="1" dirty="0">
+                <a:solidFill>
+                  <a:srgbClr val="D97706"/>
+                </a:solidFill>
+              </a:rPr>
+              <a:t>🔍 LangSmith  </a:t>
+            </a:r>
+            <a:endParaRPr lang="en-US" sz="1000" dirty="0"/>
+          </a:p>
+        </p:txBody>
+      </p:sp>
+      <p:sp>
+        <p:nvSpPr>
+          <p:cNvPr id="16" name="Text 14"/>
+          <p:cNvSpPr/>
+          <p:nvPr/>
+        </p:nvSpPr>
+        <p:spPr>
+          <a:xfrm>
+            <a:off x="1920240" y="3200400"/>
+            <a:ext cx="2286000" cy="384048"/>
+          </a:xfrm>
+          <a:prstGeom prst="rect">
+            <a:avLst/>
+          </a:prstGeom>
+          <a:noFill/>
+          <a:ln/>
+        </p:spPr>
+        <p:txBody>
+          <a:bodyPr wrap="square" lIns="0" tIns="0" rIns="0" bIns="0" rtlCol="0" anchor="ctr"/>
+          <a:lstStyle/>
+          <a:p>
+            <a:pPr marL="0" indent="0">
+              <a:buNone/>
+            </a:pPr>
+            <a:r>
+              <a:rPr lang="en-US" sz="950" dirty="0">
+                <a:solidFill>
+                  <a:srgbClr val="FFFFFF"/>
+                </a:solidFill>
+                <a:latin typeface="Courier New" pitchFamily="34" charset="0"/>
+                <a:ea typeface="Courier New" pitchFamily="34" charset="-122"/>
+                <a:cs typeface="Courier New" pitchFamily="34" charset="-120"/>
+              </a:rPr>
+              <a:t>smith.langchain.com → credit-risk-platform</a:t>
+            </a:r>
+            <a:endParaRPr lang="en-US" sz="950" dirty="0"/>
+          </a:p>
+        </p:txBody>
+      </p:sp>
+      <p:sp>
+        <p:nvSpPr>
+          <p:cNvPr id="17" name="Shape 15"/>
+          <p:cNvSpPr/>
+          <p:nvPr/>
+        </p:nvSpPr>
+        <p:spPr>
+          <a:xfrm>
+            <a:off x="4663440" y="3136392"/>
+            <a:ext cx="3520440" cy="566928"/>
+          </a:xfrm>
+          <a:prstGeom prst="roundRect">
+            <a:avLst>
+              <a:gd name="adj" fmla="val 12903"/>
+            </a:avLst>
+          </a:prstGeom>
+          <a:solidFill>
+            <a:srgbClr val="162032"/>
+          </a:solidFill>
+          <a:ln/>
+          <a:effectLst>
+            <a:outerShdw blurRad="50800" dist="25400" dir="2700000" algn="bl" rotWithShape="0">
+              <a:srgbClr val="000000">
+                <a:alpha val="12000"/>
+              </a:srgbClr>
+            </a:outerShdw>
+          </a:effectLst>
+        </p:spPr>
+      </p:sp>
+      <p:sp>
+        <p:nvSpPr>
+          <p:cNvPr id="18" name="Text 16"/>
+          <p:cNvSpPr/>
+          <p:nvPr/>
+        </p:nvSpPr>
+        <p:spPr>
+          <a:xfrm>
+            <a:off x="4846320" y="3200400"/>
+            <a:ext cx="1097280" cy="384048"/>
+          </a:xfrm>
+          <a:prstGeom prst="rect">
+            <a:avLst/>
+          </a:prstGeom>
+          <a:noFill/>
+          <a:ln/>
+        </p:spPr>
+        <p:txBody>
+          <a:bodyPr wrap="square" lIns="0" tIns="0" rIns="0" bIns="0" rtlCol="0" anchor="ctr"/>
+          <a:lstStyle/>
+          <a:p>
+            <a:pPr marL="0" indent="0">
+              <a:buNone/>
+            </a:pPr>
+            <a:r>
+              <a:rPr lang="en-US" sz="1000" b="1" dirty="0">
+                <a:solidFill>
+                  <a:srgbClr val="059669"/>
+                </a:solidFill>
+              </a:rPr>
+              <a:t>🏷️ Version  </a:t>
+            </a:r>
+            <a:endParaRPr lang="en-US" sz="1000" dirty="0"/>
+          </a:p>
+        </p:txBody>
+      </p:sp>
+      <p:sp>
+        <p:nvSpPr>
+          <p:cNvPr id="19" name="Text 17"/>
+          <p:cNvSpPr/>
+          <p:nvPr/>
+        </p:nvSpPr>
+        <p:spPr>
+          <a:xfrm>
+            <a:off x="5760720" y="3200400"/>
+            <a:ext cx="2286000" cy="384048"/>
+          </a:xfrm>
+          <a:prstGeom prst="rect">
+            <a:avLst/>
+          </a:prstGeom>
+          <a:noFill/>
+          <a:ln/>
+        </p:spPr>
+        <p:txBody>
+          <a:bodyPr wrap="square" lIns="0" tIns="0" rIns="0" bIns="0" rtlCol="0" anchor="ctr"/>
+          <a:lstStyle/>
+          <a:p>
+            <a:pPr marL="0" indent="0">
+              <a:buNone/>
+            </a:pPr>
+            <a:r>
+              <a:rPr lang="en-US" sz="950" dirty="0">
+                <a:solidFill>
+                  <a:srgbClr val="FFFFFF"/>
+                </a:solidFill>
+                <a:latin typeface="Courier New" pitchFamily="34" charset="0"/>
+                <a:ea typeface="Courier New" pitchFamily="34" charset="-122"/>
+                <a:cs typeface="Courier New" pitchFamily="34" charset="-120"/>
+              </a:rPr>
+              <a:t>git tag v1.0 — main branch</a:t>
+            </a:r>
+            <a:endParaRPr lang="en-US" sz="950" dirty="0"/>
+          </a:p>
+        </p:txBody>
+      </p:sp>
+      <p:sp>
+        <p:nvSpPr>
+          <p:cNvPr id="20" name="Text 18"/>
+          <p:cNvSpPr/>
+          <p:nvPr/>
+        </p:nvSpPr>
+        <p:spPr>
+          <a:xfrm>
+            <a:off x="457200" y="4378495"/>
+            <a:ext cx="8229600" cy="475874"/>
+          </a:xfrm>
+          <a:prstGeom prst="rect">
+            <a:avLst/>
+          </a:prstGeom>
+          <a:noFill/>
+          <a:ln/>
+        </p:spPr>
+        <p:txBody>
+          <a:bodyPr wrap="square" lIns="0" tIns="0" rIns="0" bIns="0" rtlCol="0" anchor="ctr"/>
+          <a:lstStyle/>
+          <a:p>
+            <a:pPr marL="0" indent="0" algn="ctr">
+              <a:buNone/>
+            </a:pPr>
+            <a:r>
+              <a:rPr lang="en-US" sz="1100" dirty="0">
+                <a:solidFill>
+                  <a:srgbClr val="94A3B8"/>
+                </a:solidFill>
+              </a:rPr>
+              <a:t>Akash Chaurasiya  ·  Ashu Sharma  ·  EY Training 2026  </a:t>
+            </a:r>
+            <a:endParaRPr lang="en-US" sz="1100" dirty="0"/>
+          </a:p>
+        </p:txBody>
+      </p:sp>
+    </p:spTree>
+  </p:cSld>
+  <p:clrMapOvr>
+    <a:masterClrMapping/>
+  </p:clrMapOvr>
 </p:sld>
 </file>
 

</xml_diff>

<commit_message>
adding updated PPT document
</commit_message>
<xml_diff>
--- a/Capstone_Project/Credit-Risk-Intelligence-Platform/docs/Project_Documents/Credit_Risk_Platform_Capstone_project.pptx
+++ b/Capstone_Project/Credit-Risk-Intelligence-Platform/docs/Project_Documents/Credit_Risk_Platform_Capstone_project.pptx
@@ -2044,66 +2044,6 @@
       </p:sp>
       <p:sp>
         <p:nvSpPr>
-          <p:cNvPr id="5" name="Shape 3"/>
-          <p:cNvSpPr/>
-          <p:nvPr/>
-        </p:nvSpPr>
-        <p:spPr>
-          <a:xfrm>
-            <a:off x="640080" y="822960"/>
-            <a:ext cx="1280160" cy="256032"/>
-          </a:xfrm>
-          <a:prstGeom prst="roundRect">
-            <a:avLst>
-              <a:gd name="adj" fmla="val 50000"/>
-            </a:avLst>
-          </a:prstGeom>
-          <a:solidFill>
-            <a:srgbClr val="0891B2">
-              <a:alpha val="25000"/>
-            </a:srgbClr>
-          </a:solidFill>
-          <a:ln/>
-        </p:spPr>
-      </p:sp>
-      <p:sp>
-        <p:nvSpPr>
-          <p:cNvPr id="6" name="Text 4"/>
-          <p:cNvSpPr/>
-          <p:nvPr/>
-        </p:nvSpPr>
-        <p:spPr>
-          <a:xfrm>
-            <a:off x="640080" y="822960"/>
-            <a:ext cx="1280160" cy="256032"/>
-          </a:xfrm>
-          <a:prstGeom prst="rect">
-            <a:avLst/>
-          </a:prstGeom>
-          <a:noFill/>
-          <a:ln/>
-        </p:spPr>
-        <p:txBody>
-          <a:bodyPr wrap="square" lIns="0" tIns="0" rIns="0" bIns="0" rtlCol="0" anchor="ctr"/>
-          <a:lstStyle/>
-          <a:p>
-            <a:pPr marL="0" indent="0" algn="ctr">
-              <a:buNone/>
-            </a:pPr>
-            <a:r>
-              <a:rPr lang="en-US" sz="900" b="1" kern="0" spc="150" dirty="0">
-                <a:solidFill>
-                  <a:srgbClr val="0891B2"/>
-                </a:solidFill>
-              </a:rPr>
-              <a:t>EY TRAINING 2026</a:t>
-            </a:r>
-            <a:endParaRPr lang="en-US" sz="900" dirty="0"/>
-          </a:p>
-        </p:txBody>
-      </p:sp>
-      <p:sp>
-        <p:nvSpPr>
           <p:cNvPr id="7" name="Text 5"/>
           <p:cNvSpPr/>
           <p:nvPr/>
@@ -12206,7 +12146,7 @@
                 <a:ea typeface="+mn-ea"/>
                 <a:cs typeface="+mn-cs"/>
               </a:rPr>
-              <a:t>With gratitude — built end-to-end by a 2-person team over 5 days for the EY Training 2026 Capstone, with guidance from o</a:t>
+              <a:t>With gratitude — built end-to-end by a 2-person team over 5 days with guidance from o</a:t>
             </a:r>
             <a:r>
               <a:rPr kumimoji="0" lang="en-US" sz="1050" b="0" i="0" u="none" strike="noStrike" kern="1200" cap="none" spc="0" normalizeH="0" baseline="0" noProof="0" dirty="0">
@@ -15616,7 +15556,7 @@
                 <a:ea typeface="Calibri" pitchFamily="34" charset="-122"/>
                 <a:cs typeface="Calibri" pitchFamily="34" charset="-120"/>
               </a:rPr>
-              <a:t>EY GUIDELINES · IN PRACTICE</a:t>
+              <a:t> GUIDELINES · IN PRACTICE</a:t>
             </a:r>
             <a:endParaRPr kumimoji="0" lang="en-US" sz="900" b="0" i="0" u="none" strike="noStrike" kern="1200" cap="none" spc="0" normalizeH="0" baseline="0" noProof="0" dirty="0">
               <a:ln>
@@ -15760,7 +15700,7 @@
                 <a:ea typeface="Calibri" pitchFamily="34" charset="-122"/>
                 <a:cs typeface="Calibri" pitchFamily="34" charset="-120"/>
               </a:rPr>
-              <a:t>Every EY coding principle mapped to what we actually built and shipped on the Credit Risk Intelligence Platform.</a:t>
+              <a:t>Every coding principle mapped to what we actually built and shipped on the Credit Risk Intelligence Platform.</a:t>
             </a:r>
             <a:endParaRPr kumimoji="0" lang="en-US" sz="1050" b="0" i="0" u="none" strike="noStrike" kern="1200" cap="none" spc="0" normalizeH="0" baseline="0" noProof="0" dirty="0">
               <a:ln>
@@ -17802,21 +17742,30 @@
           <a:bodyPr wrap="square" lIns="0" tIns="0" rIns="0" bIns="0" rtlCol="0" anchor="ctr"/>
           <a:lstStyle/>
           <a:p>
-            <a:pPr marL="0" indent="0">
-              <a:buNone/>
-            </a:pPr>
             <a:r>
               <a:rPr lang="en-US" sz="950" dirty="0">
                 <a:solidFill>
                   <a:srgbClr val="FFFFFF"/>
                 </a:solidFill>
                 <a:latin typeface="Courier New" pitchFamily="34" charset="0"/>
-                <a:ea typeface="Courier New" pitchFamily="34" charset="-122"/>
                 <a:cs typeface="Courier New" pitchFamily="34" charset="-120"/>
-              </a:rPr>
-              <a:t>github.com/Chaurasiyakash0136/EY-Training-2026</a:t>
-            </a:r>
-            <a:endParaRPr lang="en-US" sz="950" dirty="0"/>
+                <a:hlinkClick r:id="rId3">
+                  <a:extLst>
+                    <a:ext uri="{A12FA001-AC4F-418D-AE19-62706E023703}">
+                      <ahyp:hlinkClr xmlns:ahyp="http://schemas.microsoft.com/office/drawing/2018/hyperlinkcolor" val="tx"/>
+                    </a:ext>
+                  </a:extLst>
+                </a:hlinkClick>
+              </a:rPr>
+              <a:t>github.com/Chaurasiyakash0136/Training-2026</a:t>
+            </a:r>
+            <a:endParaRPr lang="en-US" sz="950" dirty="0">
+              <a:solidFill>
+                <a:srgbClr val="FFFFFF"/>
+              </a:solidFill>
+              <a:latin typeface="Courier New" pitchFamily="34" charset="0"/>
+              <a:cs typeface="Courier New" pitchFamily="34" charset="-120"/>
+            </a:endParaRPr>
           </a:p>
         </p:txBody>
       </p:sp>
@@ -18058,7 +18007,7 @@
                   <a:srgbClr val="94A3B8"/>
                 </a:solidFill>
               </a:rPr>
-              <a:t>Akash Chaurasiya  ·  Ashu Sharma  ·  EY Training 2026  </a:t>
+              <a:t>Akash Chaurasiya  ·  Ashu Sharma  </a:t>
             </a:r>
             <a:endParaRPr lang="en-US" sz="1100" dirty="0"/>
           </a:p>

</xml_diff>